<commit_message>
Video and deck: add 'open any app by name' scene; README and handoff
</commit_message>
<xml_diff>
--- a/submission/SRM_University_Kattankulathur_Chennai_Ciphera_s_Presentation.pptx
+++ b/submission/SRM_University_Kattankulathur_Chennai_Ciphera_s_Presentation.pptx
@@ -15,6 +15,7 @@
     <p:sldId id="263" r:id="rId15"/>
     <p:sldId id="264" r:id="rId16"/>
     <p:sldId id="265" r:id="rId17"/>
+    <p:sldId id="266" r:id="rId18"/>
   </p:sldIdLst>
   <p:sldSz cx="12191695" cy="6858000" type="screen4x3"/>
   <p:notesSz cx="6858000" cy="9144000"/>
@@ -537,6 +538,76 @@
 </file>
 
 <file path=ppt/notesSlides/notesSlide2.xml><?xml version="1.0" encoding="utf-8"?>
+<p:notes xmlns:a="http://schemas.openxmlformats.org/drawingml/2006/main" xmlns:p="http://schemas.openxmlformats.org/presentationml/2006/main" xmlns:r="http://schemas.openxmlformats.org/officeDocument/2006/relationships">
+  <p:cSld>
+    <p:spTree>
+      <p:nvGrpSpPr>
+        <p:cNvPr id="1" name=""/>
+        <p:cNvGrpSpPr/>
+        <p:nvPr/>
+      </p:nvGrpSpPr>
+      <p:grpSpPr>
+        <a:xfrm>
+          <a:off x="0" y="0"/>
+          <a:ext cx="0" cy="0"/>
+          <a:chOff x="0" y="0"/>
+          <a:chExt cx="0" cy="0"/>
+        </a:xfrm>
+      </p:grpSpPr>
+      <p:sp>
+        <p:nvSpPr>
+          <p:cNvPr id="2" name="Slide Image Placeholder 1"/>
+          <p:cNvSpPr>
+            <a:spLocks noGrp="1"/>
+          </p:cNvSpPr>
+          <p:nvPr>
+            <p:ph type="sldImg" idx="2"/>
+          </p:nvPr>
+        </p:nvSpPr>
+        <p:spPr/>
+      </p:sp>
+      <p:sp>
+        <p:nvSpPr>
+          <p:cNvPr id="3" name="Notes Placeholder 2"/>
+          <p:cNvSpPr>
+            <a:spLocks noGrp="1"/>
+          </p:cNvSpPr>
+          <p:nvPr>
+            <p:ph type="body" idx="3" sz="quarter"/>
+          </p:nvPr>
+        </p:nvSpPr>
+        <p:spPr/>
+        <p:txBody>
+          <a:bodyPr/>
+          <a:lstStyle/>
+          <a:p>
+            <a:r>
+              <a:t>Answers the first thing a user tries: opening an app. Teaching cannot capture this because launcher taps are ignored by the recorder.</a:t>
+            </a:r>
+          </a:p>
+        </p:txBody>
+      </p:sp>
+      <p:sp>
+        <p:nvSpPr>
+          <p:cNvPr id="4" name="Slide Number Placeholder 3"/>
+          <p:cNvSpPr>
+            <a:spLocks noGrp="1"/>
+          </p:cNvSpPr>
+          <p:nvPr>
+            <p:ph type="sldNum" idx="5" sz="quarter"/>
+          </p:nvPr>
+        </p:nvSpPr>
+        <p:spPr/>
+      </p:sp>
+    </p:spTree>
+  </p:cSld>
+  <p:clrMapOvr>
+    <a:masterClrMapping/>
+  </p:clrMapOvr>
+</p:notes>
+</file>
+
+<file path=ppt/notesSlides/notesSlide3.xml><?xml version="1.0" encoding="utf-8"?>
 <p:notes xmlns:a="http://schemas.openxmlformats.org/drawingml/2006/main" xmlns:p="http://schemas.openxmlformats.org/presentationml/2006/main" xmlns:r="http://schemas.openxmlformats.org/officeDocument/2006/relationships">
   <p:cSld>
     <p:spTree>
@@ -3783,6 +3854,183 @@
               </a:defRPr>
             </a:pPr>
             <a:r>
+              <a:t>Limitations, stated plainly</a:t>
+            </a:r>
+          </a:p>
+        </p:txBody>
+      </p:sp>
+      <p:sp>
+        <p:nvSpPr>
+          <p:cNvPr id="3" name="TextBox 2"/>
+          <p:cNvSpPr txBox="1"/>
+          <p:nvPr/>
+        </p:nvSpPr>
+        <p:spPr>
+          <a:xfrm>
+            <a:off x="548640" y="1463040"/>
+            <a:ext cx="10972800" cy="4572000"/>
+          </a:xfrm>
+          <a:prstGeom prst="rect">
+            <a:avLst/>
+          </a:prstGeom>
+          <a:noFill/>
+        </p:spPr>
+        <p:txBody>
+          <a:bodyPr wrap="square">
+            <a:spAutoFit/>
+          </a:bodyPr>
+          <a:lstStyle/>
+          <a:p>
+            <a:pPr>
+              <a:spcAft>
+                <a:spcPts val="800"/>
+              </a:spcAft>
+              <a:defRPr sz="1900" b="0">
+                <a:solidFill>
+                  <a:srgbClr val="F0F2F8"/>
+                </a:solidFill>
+              </a:defRPr>
+            </a:pPr>
+            <a:r>
+              <a:t>Chrome address-bar suggestion taps emit no accessibility click event, so those flows are hand-authored, not taught.</a:t>
+            </a:r>
+          </a:p>
+          <a:p>
+            <a:pPr>
+              <a:spcAft>
+                <a:spcPts val="800"/>
+              </a:spcAft>
+              <a:defRPr sz="1900" b="0">
+                <a:solidFill>
+                  <a:srgbClr val="F0F2F8"/>
+                </a:solidFill>
+              </a:defRPr>
+            </a:pPr>
+            <a:r>
+              <a:t>Long-press and drag gestures are not captured yet.</a:t>
+            </a:r>
+          </a:p>
+          <a:p>
+            <a:pPr>
+              <a:spcAft>
+                <a:spcPts val="800"/>
+              </a:spcAft>
+              <a:defRPr sz="1900" b="0">
+                <a:solidFill>
+                  <a:srgbClr val="F0F2F8"/>
+                </a:solidFill>
+              </a:defRPr>
+            </a:pPr>
+            <a:r>
+              <a:t>Operators are not slots: "plus" is baked into the taught calculator flow; "9 minus 4" needs its own demo.</a:t>
+            </a:r>
+          </a:p>
+          <a:p>
+            <a:pPr>
+              <a:spcAft>
+                <a:spcPts val="800"/>
+              </a:spcAft>
+              <a:defRPr sz="1900" b="0">
+                <a:solidFill>
+                  <a:srgbClr val="F0F2F8"/>
+                </a:solidFill>
+              </a:defRPr>
+            </a:pPr>
+            <a:r>
+              <a:t>Matching depends on an LLM (openai/gpt-oss-20b on Groq; the Llama model was not available on our key).</a:t>
+            </a:r>
+          </a:p>
+          <a:p>
+            <a:pPr>
+              <a:spcAft>
+                <a:spcPts val="800"/>
+              </a:spcAft>
+              <a:defRPr sz="1900" b="0">
+                <a:solidFill>
+                  <a:srgbClr val="F0F2F8"/>
+                </a:solidFill>
+              </a:defRPr>
+            </a:pPr>
+            <a:r>
+              <a:t>Cleartext LAN/localhost transport for development; production needs TLS.</a:t>
+            </a:r>
+          </a:p>
+          <a:p>
+            <a:pPr>
+              <a:spcAft>
+                <a:spcPts val="800"/>
+              </a:spcAft>
+              <a:defRPr sz="1900" b="0">
+                <a:solidFill>
+                  <a:srgbClr val="F0F2F8"/>
+                </a:solidFill>
+              </a:defRPr>
+            </a:pPr>
+            <a:r>
+              <a:t>Accessibility must be enabled by the user in Settings; Android does not allow it programmatically.</a:t>
+            </a:r>
+          </a:p>
+        </p:txBody>
+      </p:sp>
+    </p:spTree>
+  </p:cSld>
+  <p:clrMapOvr>
+    <a:masterClrMapping/>
+  </p:clrMapOvr>
+</p:sld>
+</file>
+
+<file path=ppt/slides/slide11.xml><?xml version="1.0" encoding="utf-8"?>
+<p:sld xmlns:a="http://schemas.openxmlformats.org/drawingml/2006/main" xmlns:p="http://schemas.openxmlformats.org/presentationml/2006/main" xmlns:r="http://schemas.openxmlformats.org/officeDocument/2006/relationships">
+  <p:cSld>
+    <p:bg>
+      <p:bgPr>
+        <a:solidFill>
+          <a:srgbClr val="12141C"/>
+        </a:solidFill>
+        <a:effectLst/>
+      </p:bgPr>
+    </p:bg>
+    <p:spTree>
+      <p:nvGrpSpPr>
+        <p:cNvPr id="1" name=""/>
+        <p:cNvGrpSpPr/>
+        <p:nvPr/>
+      </p:nvGrpSpPr>
+      <p:grpSpPr/>
+      <p:sp>
+        <p:nvSpPr>
+          <p:cNvPr id="2" name="TextBox 1"/>
+          <p:cNvSpPr txBox="1"/>
+          <p:nvPr/>
+        </p:nvSpPr>
+        <p:spPr>
+          <a:xfrm>
+            <a:off x="548640" y="365760"/>
+            <a:ext cx="10972800" cy="822960"/>
+          </a:xfrm>
+          <a:prstGeom prst="rect">
+            <a:avLst/>
+          </a:prstGeom>
+          <a:noFill/>
+        </p:spPr>
+        <p:txBody>
+          <a:bodyPr wrap="square">
+            <a:spAutoFit/>
+          </a:bodyPr>
+          <a:lstStyle/>
+          <a:p>
+            <a:pPr>
+              <a:spcAft>
+                <a:spcPts val="800"/>
+              </a:spcAft>
+              <a:defRPr sz="3400" b="1">
+                <a:solidFill>
+                  <a:srgbClr val="FFB02E"/>
+                </a:solidFill>
+              </a:defRPr>
+            </a:pPr>
+            <a:r>
               <a:t>Production: an OEM system service</a:t>
             </a:r>
           </a:p>
@@ -5198,7 +5446,7 @@
               </a:defRPr>
             </a:pPr>
             <a:r>
-              <a:t>Architecture</a:t>
+              <a:t>Open any app by name</a:t>
             </a:r>
           </a:p>
         </p:txBody>
@@ -5236,21 +5484,45 @@
               </a:defRPr>
             </a:pPr>
             <a:r>
-              <a:t>Android does the acting. The backend does the understanding.</a:t>
-            </a:r>
-          </a:p>
-        </p:txBody>
-      </p:sp>
-      <p:sp>
-        <p:nvSpPr>
-          <p:cNvPr id="4" name="Rounded Rectangle 3"/>
+              <a:t>Built in. No demonstration needed.</a:t>
+            </a:r>
+          </a:p>
+        </p:txBody>
+      </p:sp>
+      <p:pic>
+        <p:nvPicPr>
+          <p:cNvPr id="4" name="Picture 3" descr="ph_open.png"/>
+          <p:cNvPicPr>
+            <a:picLocks noChangeAspect="1"/>
+          </p:cNvPicPr>
+          <p:nvPr/>
+        </p:nvPicPr>
+        <p:blipFill>
+          <a:blip r:embed="rId2"/>
+          <a:stretch>
+            <a:fillRect/>
+          </a:stretch>
+        </p:blipFill>
+        <p:spPr>
+          <a:xfrm>
+            <a:off x="731520" y="1463040"/>
+            <a:ext cx="2169544" cy="4846320"/>
+          </a:xfrm>
+          <a:prstGeom prst="rect">
+            <a:avLst/>
+          </a:prstGeom>
+        </p:spPr>
+      </p:pic>
+      <p:sp>
+        <p:nvSpPr>
+          <p:cNvPr id="5" name="Rounded Rectangle 4"/>
           <p:cNvSpPr/>
           <p:nvPr/>
         </p:nvSpPr>
         <p:spPr>
           <a:xfrm>
-            <a:off x="548640" y="1645920"/>
-            <a:ext cx="5486400" cy="4206240"/>
+            <a:off x="3840480" y="1554480"/>
+            <a:ext cx="7772400" cy="2194560"/>
           </a:xfrm>
           <a:prstGeom prst="roundRect">
             <a:avLst/>
@@ -5286,14 +5558,14 @@
       </p:sp>
       <p:sp>
         <p:nvSpPr>
-          <p:cNvPr id="5" name="TextBox 4"/>
+          <p:cNvPr id="6" name="TextBox 5"/>
           <p:cNvSpPr txBox="1"/>
           <p:nvPr/>
         </p:nvSpPr>
         <p:spPr>
           <a:xfrm>
-            <a:off x="731520" y="1783080"/>
-            <a:ext cx="5120640" cy="457200"/>
+            <a:off x="4023360" y="1691639"/>
+            <a:ext cx="7406640" cy="457200"/>
           </a:xfrm>
           <a:prstGeom prst="rect">
             <a:avLst/>
@@ -5317,21 +5589,21 @@
               </a:defRPr>
             </a:pPr>
             <a:r>
-              <a:t>Android (Kotlin)</a:t>
-            </a:r>
-          </a:p>
-        </p:txBody>
-      </p:sp>
-      <p:sp>
-        <p:nvSpPr>
-          <p:cNvPr id="6" name="TextBox 5"/>
+              <a:t>How it works</a:t>
+            </a:r>
+          </a:p>
+        </p:txBody>
+      </p:sp>
+      <p:sp>
+        <p:nvSpPr>
+          <p:cNvPr id="7" name="TextBox 6"/>
           <p:cNvSpPr txBox="1"/>
           <p:nvPr/>
         </p:nvSpPr>
         <p:spPr>
           <a:xfrm>
-            <a:off x="731520" y="2331720"/>
-            <a:ext cx="5120640" cy="3383279"/>
+            <a:off x="4023360" y="2240280"/>
+            <a:ext cx="7406640" cy="1371600"/>
           </a:xfrm>
           <a:prstGeom prst="rect">
             <a:avLst/>
@@ -5348,44 +5620,28 @@
               <a:spcAft>
                 <a:spcPts val="800"/>
               </a:spcAft>
-              <a:defRPr sz="1500" b="0">
+              <a:defRPr sz="1700" b="0">
                 <a:solidFill>
                   <a:srgbClr val="F0F2F8"/>
                 </a:solidFill>
               </a:defRPr>
             </a:pPr>
             <a:r>
-              <a:t>AccessibilityService: read UI tree, tap, type, scroll, back</a:t>
-            </a:r>
-            <a:br/>
-            <a:r>
-              <a:t>Flow Recorder: events to selectors, passwords redacted</a:t>
-            </a:r>
-            <a:br/>
-            <a:r>
-              <a:t>Flow Replayer: resourceId &gt; text &gt; desc &gt; class, 6 s wait, retry, LLM fallback</a:t>
-            </a:r>
-            <a:br/>
-            <a:r>
-              <a:t>Overlay: draggable mic, TEACH MODE indicator, Yes/No</a:t>
-            </a:r>
-            <a:br/>
-            <a:r>
-              <a:t>Foreground service: push-to-talk audio, WebSocket, TTS playback</a:t>
-            </a:r>
-          </a:p>
-        </p:txBody>
-      </p:sp>
-      <p:sp>
-        <p:nvSpPr>
-          <p:cNvPr id="7" name="Rounded Rectangle 6"/>
+              <a:t>The phone sends the backend its launchable apps (label + package). "Open Calculator" is matched on the exact app name and the app is launched.</a:t>
+            </a:r>
+          </a:p>
+        </p:txBody>
+      </p:sp>
+      <p:sp>
+        <p:nvSpPr>
+          <p:cNvPr id="8" name="Rounded Rectangle 7"/>
           <p:cNvSpPr/>
           <p:nvPr/>
         </p:nvSpPr>
         <p:spPr>
           <a:xfrm>
-            <a:off x="6217920" y="1645920"/>
-            <a:ext cx="5486400" cy="4206240"/>
+            <a:off x="3840480" y="3931920"/>
+            <a:ext cx="7772400" cy="2194560"/>
           </a:xfrm>
           <a:prstGeom prst="roundRect">
             <a:avLst/>
@@ -5421,14 +5677,14 @@
       </p:sp>
       <p:sp>
         <p:nvSpPr>
-          <p:cNvPr id="8" name="TextBox 7"/>
+          <p:cNvPr id="9" name="TextBox 8"/>
           <p:cNvSpPr txBox="1"/>
           <p:nvPr/>
         </p:nvSpPr>
         <p:spPr>
           <a:xfrm>
-            <a:off x="6400800" y="1783080"/>
-            <a:ext cx="5120640" cy="457200"/>
+            <a:off x="4023360" y="4069080"/>
+            <a:ext cx="7406640" cy="457200"/>
           </a:xfrm>
           <a:prstGeom prst="rect">
             <a:avLst/>
@@ -5452,21 +5708,21 @@
               </a:defRPr>
             </a:pPr>
             <a:r>
-              <a:t>Backend (Node, Express, Mongo, Docker)</a:t>
-            </a:r>
-          </a:p>
-        </p:txBody>
-      </p:sp>
-      <p:sp>
-        <p:nvSpPr>
-          <p:cNvPr id="9" name="TextBox 8"/>
+              <a:t>Safe by construction</a:t>
+            </a:r>
+          </a:p>
+        </p:txBody>
+      </p:sp>
+      <p:sp>
+        <p:nvSpPr>
+          <p:cNvPr id="10" name="TextBox 9"/>
           <p:cNvSpPr txBox="1"/>
           <p:nvPr/>
         </p:nvSpPr>
         <p:spPr>
           <a:xfrm>
-            <a:off x="6400800" y="2331720"/>
-            <a:ext cx="5120640" cy="3383279"/>
+            <a:off x="4023360" y="4617720"/>
+            <a:ext cx="7406640" cy="1371600"/>
           </a:xfrm>
           <a:prstGeom prst="rect">
             <a:avLst/>
@@ -5483,34 +5739,14 @@
               <a:spcAft>
                 <a:spcPts val="800"/>
               </a:spcAft>
-              <a:defRPr sz="1500" b="0">
+              <a:defRPr sz="1700" b="0">
                 <a:solidFill>
                   <a:srgbClr val="F0F2F8"/>
                 </a:solidFill>
               </a:defRPr>
             </a:pPr>
             <a:r>
-              <a:t>WebSocket: audio to Deepgram Nova 3 STT</a:t>
-            </a:r>
-            <a:br/>
-            <a:r>
-              <a:t>Groq JSON mode: intent + slots, generalise, paraphrase match, pick-element fallback</a:t>
-            </a:r>
-            <a:br/>
-            <a:r>
-              <a:t>Deepgram Aura TTS over the same socket</a:t>
-            </a:r>
-            <a:br/>
-            <a:r>
-              <a:t>Mongo: Flow + RunLog</a:t>
-            </a:r>
-            <a:br/>
-            <a:r>
-              <a:t>REST + /dashboard metrics from real RunLogs</a:t>
-            </a:r>
-            <a:br/>
-            <a:r>
-              <a:t>docker compose up</a:t>
+              <a:t>Exact-name match only, so "open Bluetooth settings" still replays your taught flow instead of hitting the Settings app. Unknown names fall back to teach mode.</a:t>
             </a:r>
           </a:p>
         </p:txBody>
@@ -5574,21 +5810,59 @@
               </a:defRPr>
             </a:pPr>
             <a:r>
-              <a:t>Why Accessibility beats app-specific integrations</a:t>
-            </a:r>
-          </a:p>
-        </p:txBody>
-      </p:sp>
-      <p:sp>
-        <p:nvSpPr>
-          <p:cNvPr id="3" name="Rounded Rectangle 2"/>
+              <a:t>Architecture</a:t>
+            </a:r>
+          </a:p>
+        </p:txBody>
+      </p:sp>
+      <p:sp>
+        <p:nvSpPr>
+          <p:cNvPr id="3" name="TextBox 2"/>
+          <p:cNvSpPr txBox="1"/>
+          <p:nvPr/>
+        </p:nvSpPr>
+        <p:spPr>
+          <a:xfrm>
+            <a:off x="548640" y="1097280"/>
+            <a:ext cx="10972800" cy="457200"/>
+          </a:xfrm>
+          <a:prstGeom prst="rect">
+            <a:avLst/>
+          </a:prstGeom>
+          <a:noFill/>
+        </p:spPr>
+        <p:txBody>
+          <a:bodyPr wrap="square">
+            <a:spAutoFit/>
+          </a:bodyPr>
+          <a:lstStyle/>
+          <a:p>
+            <a:pPr>
+              <a:spcAft>
+                <a:spcPts val="800"/>
+              </a:spcAft>
+              <a:defRPr sz="1600" b="0">
+                <a:solidFill>
+                  <a:srgbClr val="969EB0"/>
+                </a:solidFill>
+              </a:defRPr>
+            </a:pPr>
+            <a:r>
+              <a:t>Android does the acting. The backend does the understanding.</a:t>
+            </a:r>
+          </a:p>
+        </p:txBody>
+      </p:sp>
+      <p:sp>
+        <p:nvSpPr>
+          <p:cNvPr id="4" name="Rounded Rectangle 3"/>
           <p:cNvSpPr/>
           <p:nvPr/>
         </p:nvSpPr>
         <p:spPr>
           <a:xfrm>
-            <a:off x="548640" y="1463040"/>
-            <a:ext cx="5394960" cy="4389120"/>
+            <a:off x="548640" y="1645920"/>
+            <a:ext cx="5486400" cy="4206240"/>
           </a:xfrm>
           <a:prstGeom prst="roundRect">
             <a:avLst/>
@@ -5624,14 +5898,14 @@
       </p:sp>
       <p:sp>
         <p:nvSpPr>
-          <p:cNvPr id="4" name="TextBox 3"/>
+          <p:cNvPr id="5" name="TextBox 4"/>
           <p:cNvSpPr txBox="1"/>
           <p:nvPr/>
         </p:nvSpPr>
         <p:spPr>
           <a:xfrm>
-            <a:off x="731520" y="1600200"/>
-            <a:ext cx="5029200" cy="457200"/>
+            <a:off x="731520" y="1783080"/>
+            <a:ext cx="5120640" cy="457200"/>
           </a:xfrm>
           <a:prstGeom prst="rect">
             <a:avLst/>
@@ -5655,21 +5929,21 @@
               </a:defRPr>
             </a:pPr>
             <a:r>
-              <a:t>Per-app integration</a:t>
-            </a:r>
-          </a:p>
-        </p:txBody>
-      </p:sp>
-      <p:sp>
-        <p:nvSpPr>
-          <p:cNvPr id="5" name="TextBox 4"/>
+              <a:t>Android (Kotlin)</a:t>
+            </a:r>
+          </a:p>
+        </p:txBody>
+      </p:sp>
+      <p:sp>
+        <p:nvSpPr>
+          <p:cNvPr id="6" name="TextBox 5"/>
           <p:cNvSpPr txBox="1"/>
           <p:nvPr/>
         </p:nvSpPr>
         <p:spPr>
           <a:xfrm>
-            <a:off x="731520" y="2148840"/>
-            <a:ext cx="5029200" cy="3566160"/>
+            <a:off x="731520" y="2331720"/>
+            <a:ext cx="5120640" cy="3383279"/>
           </a:xfrm>
           <a:prstGeom prst="rect">
             <a:avLst/>
@@ -5686,36 +5960,44 @@
               <a:spcAft>
                 <a:spcPts val="800"/>
               </a:spcAft>
-              <a:defRPr sz="1700" b="0">
+              <a:defRPr sz="1500" b="0">
                 <a:solidFill>
                   <a:srgbClr val="F0F2F8"/>
                 </a:solidFill>
               </a:defRPr>
             </a:pPr>
             <a:r>
-              <a:t>One integration per app, built by that app's developer</a:t>
+              <a:t>AccessibilityService: read UI tree, tap, type, scroll, back</a:t>
             </a:r>
             <a:br/>
             <a:r>
-              <a:t>Breaks when the app ships an update they did not plan for</a:t>
+              <a:t>Flow Recorder: events to selectors, passwords redacted</a:t>
             </a:r>
             <a:br/>
             <a:r>
-              <a:t>Covers only partners</a:t>
-            </a:r>
-          </a:p>
-        </p:txBody>
-      </p:sp>
-      <p:sp>
-        <p:nvSpPr>
-          <p:cNvPr id="6" name="Rounded Rectangle 5"/>
+              <a:t>Flow Replayer: resourceId &gt; text &gt; desc &gt; class, 6 s wait, retry, LLM fallback</a:t>
+            </a:r>
+            <a:br/>
+            <a:r>
+              <a:t>Overlay: draggable mic, TEACH MODE indicator, Yes/No</a:t>
+            </a:r>
+            <a:br/>
+            <a:r>
+              <a:t>Foreground service: push-to-talk audio, WebSocket, TTS playback</a:t>
+            </a:r>
+          </a:p>
+        </p:txBody>
+      </p:sp>
+      <p:sp>
+        <p:nvSpPr>
+          <p:cNvPr id="7" name="Rounded Rectangle 6"/>
           <p:cNvSpPr/>
           <p:nvPr/>
         </p:nvSpPr>
         <p:spPr>
           <a:xfrm>
-            <a:off x="6217920" y="1463040"/>
-            <a:ext cx="5394960" cy="4389120"/>
+            <a:off x="6217920" y="1645920"/>
+            <a:ext cx="5486400" cy="4206240"/>
           </a:xfrm>
           <a:prstGeom prst="roundRect">
             <a:avLst/>
@@ -5751,14 +6033,14 @@
       </p:sp>
       <p:sp>
         <p:nvSpPr>
-          <p:cNvPr id="7" name="TextBox 6"/>
+          <p:cNvPr id="8" name="TextBox 7"/>
           <p:cNvSpPr txBox="1"/>
           <p:nvPr/>
         </p:nvSpPr>
         <p:spPr>
           <a:xfrm>
-            <a:off x="6400800" y="1600200"/>
-            <a:ext cx="5029200" cy="457200"/>
+            <a:off x="6400800" y="1783080"/>
+            <a:ext cx="5120640" cy="457200"/>
           </a:xfrm>
           <a:prstGeom prst="rect">
             <a:avLst/>
@@ -5782,21 +6064,21 @@
               </a:defRPr>
             </a:pPr>
             <a:r>
-              <a:t>Accessibility + demonstration</a:t>
-            </a:r>
-          </a:p>
-        </p:txBody>
-      </p:sp>
-      <p:sp>
-        <p:nvSpPr>
-          <p:cNvPr id="8" name="TextBox 7"/>
+              <a:t>Backend (Node, Express, Mongo, Docker)</a:t>
+            </a:r>
+          </a:p>
+        </p:txBody>
+      </p:sp>
+      <p:sp>
+        <p:nvSpPr>
+          <p:cNvPr id="9" name="TextBox 8"/>
           <p:cNvSpPr txBox="1"/>
           <p:nvPr/>
         </p:nvSpPr>
         <p:spPr>
           <a:xfrm>
-            <a:off x="6400800" y="2148840"/>
-            <a:ext cx="5029200" cy="3566160"/>
+            <a:off x="6400800" y="2331720"/>
+            <a:ext cx="5120640" cy="3383279"/>
           </a:xfrm>
           <a:prstGeom prst="rect">
             <a:avLst/>
@@ -5813,26 +6095,34 @@
               <a:spcAft>
                 <a:spcPts val="800"/>
               </a:spcAft>
-              <a:defRPr sz="1700" b="0">
+              <a:defRPr sz="1500" b="0">
                 <a:solidFill>
                   <a:srgbClr val="F0F2F8"/>
                 </a:solidFill>
               </a:defRPr>
             </a:pPr>
             <a:r>
-              <a:t>Works on apps that know nothing about us</a:t>
+              <a:t>WebSocket: audio to Deepgram Nova 3 STT</a:t>
             </a:r>
             <a:br/>
             <a:r>
-              <a:t>The user is the integration: one demo, minutes not months</a:t>
+              <a:t>Groq JSON mode: intent + slots, generalise, paraphrase match, pick-element fallback</a:t>
             </a:r>
             <a:br/>
             <a:r>
-              <a:t>Same UI tree screen readers already use</a:t>
+              <a:t>Deepgram Aura TTS over the same socket</a:t>
             </a:r>
             <a:br/>
             <a:r>
-              <a:t>Covers the long tail, including Chrome, Settings, Clock, Calculator</a:t>
+              <a:t>Mongo: Flow + RunLog</a:t>
+            </a:r>
+            <a:br/>
+            <a:r>
+              <a:t>REST + /dashboard metrics from real RunLogs</a:t>
+            </a:r>
+            <a:br/>
+            <a:r>
+              <a:t>docker compose up</a:t>
             </a:r>
           </a:p>
         </p:txBody>
@@ -5896,21 +6186,64 @@
               </a:defRPr>
             </a:pPr>
             <a:r>
-              <a:t>Demo on a real phone</a:t>
-            </a:r>
-          </a:p>
-        </p:txBody>
-      </p:sp>
-      <p:sp>
-        <p:nvSpPr>
-          <p:cNvPr id="3" name="TextBox 2"/>
+              <a:t>Why Accessibility beats app-specific integrations</a:t>
+            </a:r>
+          </a:p>
+        </p:txBody>
+      </p:sp>
+      <p:sp>
+        <p:nvSpPr>
+          <p:cNvPr id="3" name="Rounded Rectangle 2"/>
+          <p:cNvSpPr/>
+          <p:nvPr/>
+        </p:nvSpPr>
+        <p:spPr>
+          <a:xfrm>
+            <a:off x="548640" y="1463040"/>
+            <a:ext cx="5394960" cy="4389120"/>
+          </a:xfrm>
+          <a:prstGeom prst="roundRect">
+            <a:avLst/>
+          </a:prstGeom>
+          <a:solidFill>
+            <a:srgbClr val="1F2330"/>
+          </a:solidFill>
+          <a:ln>
+            <a:noFill/>
+          </a:ln>
+        </p:spPr>
+        <p:style>
+          <a:lnRef idx="1">
+            <a:schemeClr val="accent1"/>
+          </a:lnRef>
+          <a:fillRef idx="3">
+            <a:schemeClr val="accent1"/>
+          </a:fillRef>
+          <a:effectRef idx="2">
+            <a:schemeClr val="accent1"/>
+          </a:effectRef>
+          <a:fontRef idx="minor">
+            <a:schemeClr val="lt1"/>
+          </a:fontRef>
+        </p:style>
+        <p:txBody>
+          <a:bodyPr rtlCol="0" anchor="ctr"/>
+          <a:lstStyle/>
+          <a:p>
+            <a:pPr algn="ctr"/>
+          </a:p>
+        </p:txBody>
+      </p:sp>
+      <p:sp>
+        <p:nvSpPr>
+          <p:cNvPr id="4" name="TextBox 3"/>
           <p:cNvSpPr txBox="1"/>
           <p:nvPr/>
         </p:nvSpPr>
         <p:spPr>
           <a:xfrm>
-            <a:off x="548640" y="1097280"/>
-            <a:ext cx="10972800" cy="457200"/>
+            <a:off x="731520" y="1600200"/>
+            <a:ext cx="5029200" cy="457200"/>
           </a:xfrm>
           <a:prstGeom prst="rect">
             <a:avLst/>
@@ -5927,42 +6260,18 @@
               <a:spcAft>
                 <a:spcPts val="800"/>
               </a:spcAft>
-              <a:defRPr sz="1600" b="0">
-                <a:solidFill>
-                  <a:srgbClr val="969EB0"/>
+              <a:defRPr sz="2000" b="1">
+                <a:solidFill>
+                  <a:srgbClr val="FFB02E"/>
                 </a:solidFill>
               </a:defRPr>
             </a:pPr>
             <a:r>
-              <a:t>Realme device, real Accessibility events, real STT and TTS.</a:t>
-            </a:r>
-          </a:p>
-        </p:txBody>
-      </p:sp>
-      <p:pic>
-        <p:nvPicPr>
-          <p:cNvPr id="4" name="Picture 3" descr="ph_teach.png"/>
-          <p:cNvPicPr>
-            <a:picLocks noChangeAspect="1"/>
-          </p:cNvPicPr>
-          <p:nvPr/>
-        </p:nvPicPr>
-        <p:blipFill>
-          <a:blip r:embed="rId2"/>
-          <a:stretch>
-            <a:fillRect/>
-          </a:stretch>
-        </p:blipFill>
-        <p:spPr>
-          <a:xfrm>
-            <a:off x="822960" y="1554480"/>
-            <a:ext cx="1923936" cy="4297680"/>
-          </a:xfrm>
-          <a:prstGeom prst="rect">
-            <a:avLst/>
-          </a:prstGeom>
-        </p:spPr>
-      </p:pic>
+              <a:t>Per-app integration</a:t>
+            </a:r>
+          </a:p>
+        </p:txBody>
+      </p:sp>
       <p:sp>
         <p:nvSpPr>
           <p:cNvPr id="5" name="TextBox 4"/>
@@ -5971,8 +6280,8 @@
         </p:nvSpPr>
         <p:spPr>
           <a:xfrm>
-            <a:off x="822960" y="5943600"/>
-            <a:ext cx="3291840" cy="457200"/>
+            <a:off x="731520" y="2148840"/>
+            <a:ext cx="5029200" cy="3566160"/>
           </a:xfrm>
           <a:prstGeom prst="rect">
             <a:avLst/>
@@ -5989,42 +6298,69 @@
               <a:spcAft>
                 <a:spcPts val="800"/>
               </a:spcAft>
-              <a:defRPr sz="1500" b="0">
-                <a:solidFill>
-                  <a:srgbClr val="969EB0"/>
+              <a:defRPr sz="1700" b="0">
+                <a:solidFill>
+                  <a:srgbClr val="F0F2F8"/>
                 </a:solidFill>
               </a:defRPr>
             </a:pPr>
             <a:r>
-              <a:t>Teach mode: user demonstrates</a:t>
-            </a:r>
-          </a:p>
-        </p:txBody>
-      </p:sp>
-      <p:pic>
-        <p:nvPicPr>
-          <p:cNvPr id="6" name="Picture 5" descr="ph_replay.png"/>
-          <p:cNvPicPr>
-            <a:picLocks noChangeAspect="1"/>
-          </p:cNvPicPr>
-          <p:nvPr/>
-        </p:nvPicPr>
-        <p:blipFill>
-          <a:blip r:embed="rId3"/>
-          <a:stretch>
-            <a:fillRect/>
-          </a:stretch>
-        </p:blipFill>
-        <p:spPr>
-          <a:xfrm>
-            <a:off x="4572000" y="1554480"/>
-            <a:ext cx="1923936" cy="4297680"/>
-          </a:xfrm>
-          <a:prstGeom prst="rect">
-            <a:avLst/>
-          </a:prstGeom>
-        </p:spPr>
-      </p:pic>
+              <a:t>One integration per app, built by that app's developer</a:t>
+            </a:r>
+            <a:br/>
+            <a:r>
+              <a:t>Breaks when the app ships an update they did not plan for</a:t>
+            </a:r>
+            <a:br/>
+            <a:r>
+              <a:t>Covers only partners</a:t>
+            </a:r>
+          </a:p>
+        </p:txBody>
+      </p:sp>
+      <p:sp>
+        <p:nvSpPr>
+          <p:cNvPr id="6" name="Rounded Rectangle 5"/>
+          <p:cNvSpPr/>
+          <p:nvPr/>
+        </p:nvSpPr>
+        <p:spPr>
+          <a:xfrm>
+            <a:off x="6217920" y="1463040"/>
+            <a:ext cx="5394960" cy="4389120"/>
+          </a:xfrm>
+          <a:prstGeom prst="roundRect">
+            <a:avLst/>
+          </a:prstGeom>
+          <a:solidFill>
+            <a:srgbClr val="1F2330"/>
+          </a:solidFill>
+          <a:ln>
+            <a:noFill/>
+          </a:ln>
+        </p:spPr>
+        <p:style>
+          <a:lnRef idx="1">
+            <a:schemeClr val="accent1"/>
+          </a:lnRef>
+          <a:fillRef idx="3">
+            <a:schemeClr val="accent1"/>
+          </a:fillRef>
+          <a:effectRef idx="2">
+            <a:schemeClr val="accent1"/>
+          </a:effectRef>
+          <a:fontRef idx="minor">
+            <a:schemeClr val="lt1"/>
+          </a:fontRef>
+        </p:style>
+        <p:txBody>
+          <a:bodyPr rtlCol="0" anchor="ctr"/>
+          <a:lstStyle/>
+          <a:p>
+            <a:pPr algn="ctr"/>
+          </a:p>
+        </p:txBody>
+      </p:sp>
       <p:sp>
         <p:nvSpPr>
           <p:cNvPr id="7" name="TextBox 6"/>
@@ -6033,8 +6369,8 @@
         </p:nvSpPr>
         <p:spPr>
           <a:xfrm>
-            <a:off x="4572000" y="5943600"/>
-            <a:ext cx="3291840" cy="457200"/>
+            <a:off x="6400800" y="1600200"/>
+            <a:ext cx="5029200" cy="457200"/>
           </a:xfrm>
           <a:prstGeom prst="rect">
             <a:avLst/>
@@ -6051,52 +6387,28 @@
               <a:spcAft>
                 <a:spcPts val="800"/>
               </a:spcAft>
-              <a:defRPr sz="1500" b="0">
-                <a:solidFill>
-                  <a:srgbClr val="969EB0"/>
+              <a:defRPr sz="2000" b="1">
+                <a:solidFill>
+                  <a:srgbClr val="FFB02E"/>
                 </a:solidFill>
               </a:defRPr>
             </a:pPr>
             <a:r>
-              <a:t>New slot, same flow: 9 + 4 = 13</a:t>
-            </a:r>
-          </a:p>
-        </p:txBody>
-      </p:sp>
-      <p:pic>
-        <p:nvPicPr>
-          <p:cNvPr id="8" name="Picture 7" descr="ph_confirm.png"/>
-          <p:cNvPicPr>
-            <a:picLocks noChangeAspect="1"/>
-          </p:cNvPicPr>
-          <p:nvPr/>
-        </p:nvPicPr>
-        <p:blipFill>
-          <a:blip r:embed="rId4"/>
-          <a:stretch>
-            <a:fillRect/>
-          </a:stretch>
-        </p:blipFill>
-        <p:spPr>
-          <a:xfrm>
-            <a:off x="8321040" y="1554480"/>
-            <a:ext cx="1923936" cy="4297680"/>
-          </a:xfrm>
-          <a:prstGeom prst="rect">
-            <a:avLst/>
-          </a:prstGeom>
-        </p:spPr>
-      </p:pic>
-      <p:sp>
-        <p:nvSpPr>
-          <p:cNvPr id="9" name="TextBox 8"/>
+              <a:t>Accessibility + demonstration</a:t>
+            </a:r>
+          </a:p>
+        </p:txBody>
+      </p:sp>
+      <p:sp>
+        <p:nvSpPr>
+          <p:cNvPr id="8" name="TextBox 7"/>
           <p:cNvSpPr txBox="1"/>
           <p:nvPr/>
         </p:nvSpPr>
         <p:spPr>
           <a:xfrm>
-            <a:off x="8321040" y="5943600"/>
-            <a:ext cx="3291840" cy="457200"/>
+            <a:off x="6400800" y="2148840"/>
+            <a:ext cx="5029200" cy="3566160"/>
           </a:xfrm>
           <a:prstGeom prst="rect">
             <a:avLst/>
@@ -6113,14 +6425,26 @@
               <a:spcAft>
                 <a:spcPts val="800"/>
               </a:spcAft>
-              <a:defRPr sz="1500" b="0">
-                <a:solidFill>
-                  <a:srgbClr val="969EB0"/>
+              <a:defRPr sz="1700" b="0">
+                <a:solidFill>
+                  <a:srgbClr val="F0F2F8"/>
                 </a:solidFill>
               </a:defRPr>
             </a:pPr>
             <a:r>
-              <a:t>Confirm before sensitive step</a:t>
+              <a:t>Works on apps that know nothing about us</a:t>
+            </a:r>
+            <a:br/>
+            <a:r>
+              <a:t>The user is the integration: one demo, minutes not months</a:t>
+            </a:r>
+            <a:br/>
+            <a:r>
+              <a:t>Same UI tree screen readers already use</a:t>
+            </a:r>
+            <a:br/>
+            <a:r>
+              <a:t>Covers the long tail, including Chrome, Settings, Clock, Calculator</a:t>
             </a:r>
           </a:p>
         </p:txBody>
@@ -6184,7 +6508,7 @@
               </a:defRPr>
             </a:pPr>
             <a:r>
-              <a:t>Measured results</a:t>
+              <a:t>Demo on a real phone</a:t>
             </a:r>
           </a:p>
         </p:txBody>
@@ -6222,485 +6546,14 @@
               </a:defRPr>
             </a:pPr>
             <a:r>
-              <a:t>Real phone. Flows and RunLogs reset first. Computed by the dashboard from RunLog data.</a:t>
-            </a:r>
-          </a:p>
-        </p:txBody>
-      </p:sp>
-      <p:sp>
-        <p:nvSpPr>
-          <p:cNvPr id="4" name="Rounded Rectangle 3"/>
-          <p:cNvSpPr/>
-          <p:nvPr/>
-        </p:nvSpPr>
-        <p:spPr>
-          <a:xfrm>
-            <a:off x="548640" y="1645920"/>
-            <a:ext cx="3566160" cy="2194560"/>
-          </a:xfrm>
-          <a:prstGeom prst="roundRect">
-            <a:avLst/>
-          </a:prstGeom>
-          <a:solidFill>
-            <a:srgbClr val="1F2330"/>
-          </a:solidFill>
-          <a:ln>
-            <a:noFill/>
-          </a:ln>
-        </p:spPr>
-        <p:style>
-          <a:lnRef idx="1">
-            <a:schemeClr val="accent1"/>
-          </a:lnRef>
-          <a:fillRef idx="3">
-            <a:schemeClr val="accent1"/>
-          </a:fillRef>
-          <a:effectRef idx="2">
-            <a:schemeClr val="accent1"/>
-          </a:effectRef>
-          <a:fontRef idx="minor">
-            <a:schemeClr val="lt1"/>
-          </a:fontRef>
-        </p:style>
-        <p:txBody>
-          <a:bodyPr rtlCol="0" anchor="ctr"/>
-          <a:lstStyle/>
-          <a:p>
-            <a:pPr algn="ctr"/>
-          </a:p>
-        </p:txBody>
-      </p:sp>
-      <p:sp>
-        <p:nvSpPr>
-          <p:cNvPr id="5" name="TextBox 4"/>
-          <p:cNvSpPr txBox="1"/>
-          <p:nvPr/>
-        </p:nvSpPr>
-        <p:spPr>
-          <a:xfrm>
-            <a:off x="731520" y="1783080"/>
-            <a:ext cx="3200400" cy="457200"/>
-          </a:xfrm>
-          <a:prstGeom prst="rect">
-            <a:avLst/>
-          </a:prstGeom>
-          <a:noFill/>
-        </p:spPr>
-        <p:txBody>
-          <a:bodyPr wrap="square">
-            <a:spAutoFit/>
-          </a:bodyPr>
-          <a:lstStyle/>
-          <a:p>
-            <a:pPr>
-              <a:spcAft>
-                <a:spcPts val="800"/>
-              </a:spcAft>
-              <a:defRPr sz="2000" b="1">
-                <a:solidFill>
-                  <a:srgbClr val="FFB02E"/>
-                </a:solidFill>
-              </a:defRPr>
-            </a:pPr>
-            <a:r>
-              <a:t>Learn success</a:t>
-            </a:r>
-          </a:p>
-        </p:txBody>
-      </p:sp>
-      <p:sp>
-        <p:nvSpPr>
-          <p:cNvPr id="6" name="TextBox 5"/>
-          <p:cNvSpPr txBox="1"/>
-          <p:nvPr/>
-        </p:nvSpPr>
-        <p:spPr>
-          <a:xfrm>
-            <a:off x="731520" y="2331720"/>
-            <a:ext cx="3200400" cy="1371600"/>
-          </a:xfrm>
-          <a:prstGeom prst="rect">
-            <a:avLst/>
-          </a:prstGeom>
-          <a:noFill/>
-        </p:spPr>
-        <p:txBody>
-          <a:bodyPr wrap="square">
-            <a:spAutoFit/>
-          </a:bodyPr>
-          <a:lstStyle/>
-          <a:p>
-            <a:pPr>
-              <a:spcAft>
-                <a:spcPts val="800"/>
-              </a:spcAft>
-              <a:defRPr sz="1500" b="0">
-                <a:solidFill>
-                  <a:srgbClr val="F0F2F8"/>
-                </a:solidFill>
-              </a:defRPr>
-            </a:pPr>
-            <a:r>
-              <a:t>100%</a:t>
-            </a:r>
-          </a:p>
-        </p:txBody>
-      </p:sp>
-      <p:sp>
-        <p:nvSpPr>
-          <p:cNvPr id="7" name="TextBox 6"/>
-          <p:cNvSpPr txBox="1"/>
-          <p:nvPr/>
-        </p:nvSpPr>
-        <p:spPr>
-          <a:xfrm>
-            <a:off x="731520" y="3063240"/>
-            <a:ext cx="3200400" cy="731520"/>
-          </a:xfrm>
-          <a:prstGeom prst="rect">
-            <a:avLst/>
-          </a:prstGeom>
-          <a:noFill/>
-        </p:spPr>
-        <p:txBody>
-          <a:bodyPr wrap="square">
-            <a:spAutoFit/>
-          </a:bodyPr>
-          <a:lstStyle/>
-          <a:p>
-            <a:pPr>
-              <a:spcAft>
-                <a:spcPts val="800"/>
-              </a:spcAft>
-              <a:defRPr sz="1400" b="0">
-                <a:solidFill>
-                  <a:srgbClr val="969EB0"/>
-                </a:solidFill>
-              </a:defRPr>
-            </a:pPr>
-            <a:r>
-              <a:t>3 / 3 demonstrations turned into flows</a:t>
-            </a:r>
-          </a:p>
-        </p:txBody>
-      </p:sp>
-      <p:sp>
-        <p:nvSpPr>
-          <p:cNvPr id="8" name="Rounded Rectangle 7"/>
-          <p:cNvSpPr/>
-          <p:nvPr/>
-        </p:nvSpPr>
-        <p:spPr>
-          <a:xfrm>
-            <a:off x="4343400" y="1645920"/>
-            <a:ext cx="3566160" cy="2194560"/>
-          </a:xfrm>
-          <a:prstGeom prst="roundRect">
-            <a:avLst/>
-          </a:prstGeom>
-          <a:solidFill>
-            <a:srgbClr val="1F2330"/>
-          </a:solidFill>
-          <a:ln>
-            <a:noFill/>
-          </a:ln>
-        </p:spPr>
-        <p:style>
-          <a:lnRef idx="1">
-            <a:schemeClr val="accent1"/>
-          </a:lnRef>
-          <a:fillRef idx="3">
-            <a:schemeClr val="accent1"/>
-          </a:fillRef>
-          <a:effectRef idx="2">
-            <a:schemeClr val="accent1"/>
-          </a:effectRef>
-          <a:fontRef idx="minor">
-            <a:schemeClr val="lt1"/>
-          </a:fontRef>
-        </p:style>
-        <p:txBody>
-          <a:bodyPr rtlCol="0" anchor="ctr"/>
-          <a:lstStyle/>
-          <a:p>
-            <a:pPr algn="ctr"/>
-          </a:p>
-        </p:txBody>
-      </p:sp>
-      <p:sp>
-        <p:nvSpPr>
-          <p:cNvPr id="9" name="TextBox 8"/>
-          <p:cNvSpPr txBox="1"/>
-          <p:nvPr/>
-        </p:nvSpPr>
-        <p:spPr>
-          <a:xfrm>
-            <a:off x="4526280" y="1783080"/>
-            <a:ext cx="3200400" cy="457200"/>
-          </a:xfrm>
-          <a:prstGeom prst="rect">
-            <a:avLst/>
-          </a:prstGeom>
-          <a:noFill/>
-        </p:spPr>
-        <p:txBody>
-          <a:bodyPr wrap="square">
-            <a:spAutoFit/>
-          </a:bodyPr>
-          <a:lstStyle/>
-          <a:p>
-            <a:pPr>
-              <a:spcAft>
-                <a:spcPts val="800"/>
-              </a:spcAft>
-              <a:defRPr sz="2000" b="1">
-                <a:solidFill>
-                  <a:srgbClr val="FFB02E"/>
-                </a:solidFill>
-              </a:defRPr>
-            </a:pPr>
-            <a:r>
-              <a:t>Replay success</a:t>
-            </a:r>
-          </a:p>
-        </p:txBody>
-      </p:sp>
-      <p:sp>
-        <p:nvSpPr>
-          <p:cNvPr id="10" name="TextBox 9"/>
-          <p:cNvSpPr txBox="1"/>
-          <p:nvPr/>
-        </p:nvSpPr>
-        <p:spPr>
-          <a:xfrm>
-            <a:off x="4526280" y="2331720"/>
-            <a:ext cx="3200400" cy="1371600"/>
-          </a:xfrm>
-          <a:prstGeom prst="rect">
-            <a:avLst/>
-          </a:prstGeom>
-          <a:noFill/>
-        </p:spPr>
-        <p:txBody>
-          <a:bodyPr wrap="square">
-            <a:spAutoFit/>
-          </a:bodyPr>
-          <a:lstStyle/>
-          <a:p>
-            <a:pPr>
-              <a:spcAft>
-                <a:spcPts val="800"/>
-              </a:spcAft>
-              <a:defRPr sz="1500" b="0">
-                <a:solidFill>
-                  <a:srgbClr val="F0F2F8"/>
-                </a:solidFill>
-              </a:defRPr>
-            </a:pPr>
-            <a:r>
-              <a:t>100%</a:t>
-            </a:r>
-          </a:p>
-        </p:txBody>
-      </p:sp>
-      <p:sp>
-        <p:nvSpPr>
-          <p:cNvPr id="11" name="TextBox 10"/>
-          <p:cNvSpPr txBox="1"/>
-          <p:nvPr/>
-        </p:nvSpPr>
-        <p:spPr>
-          <a:xfrm>
-            <a:off x="4526280" y="3063240"/>
-            <a:ext cx="3200400" cy="731520"/>
-          </a:xfrm>
-          <a:prstGeom prst="rect">
-            <a:avLst/>
-          </a:prstGeom>
-          <a:noFill/>
-        </p:spPr>
-        <p:txBody>
-          <a:bodyPr wrap="square">
-            <a:spAutoFit/>
-          </a:bodyPr>
-          <a:lstStyle/>
-          <a:p>
-            <a:pPr>
-              <a:spcAft>
-                <a:spcPts val="800"/>
-              </a:spcAft>
-              <a:defRPr sz="1400" b="0">
-                <a:solidFill>
-                  <a:srgbClr val="969EB0"/>
-                </a:solidFill>
-              </a:defRPr>
-            </a:pPr>
-            <a:r>
-              <a:t>9 / 9 replays with new slot values</a:t>
-            </a:r>
-          </a:p>
-        </p:txBody>
-      </p:sp>
-      <p:sp>
-        <p:nvSpPr>
-          <p:cNvPr id="12" name="Rounded Rectangle 11"/>
-          <p:cNvSpPr/>
-          <p:nvPr/>
-        </p:nvSpPr>
-        <p:spPr>
-          <a:xfrm>
-            <a:off x="8138160" y="1645920"/>
-            <a:ext cx="3566160" cy="2194560"/>
-          </a:xfrm>
-          <a:prstGeom prst="roundRect">
-            <a:avLst/>
-          </a:prstGeom>
-          <a:solidFill>
-            <a:srgbClr val="1F2330"/>
-          </a:solidFill>
-          <a:ln>
-            <a:noFill/>
-          </a:ln>
-        </p:spPr>
-        <p:style>
-          <a:lnRef idx="1">
-            <a:schemeClr val="accent1"/>
-          </a:lnRef>
-          <a:fillRef idx="3">
-            <a:schemeClr val="accent1"/>
-          </a:fillRef>
-          <a:effectRef idx="2">
-            <a:schemeClr val="accent1"/>
-          </a:effectRef>
-          <a:fontRef idx="minor">
-            <a:schemeClr val="lt1"/>
-          </a:fontRef>
-        </p:style>
-        <p:txBody>
-          <a:bodyPr rtlCol="0" anchor="ctr"/>
-          <a:lstStyle/>
-          <a:p>
-            <a:pPr algn="ctr"/>
-          </a:p>
-        </p:txBody>
-      </p:sp>
-      <p:sp>
-        <p:nvSpPr>
-          <p:cNvPr id="13" name="TextBox 12"/>
-          <p:cNvSpPr txBox="1"/>
-          <p:nvPr/>
-        </p:nvSpPr>
-        <p:spPr>
-          <a:xfrm>
-            <a:off x="8321040" y="1783080"/>
-            <a:ext cx="3200400" cy="457200"/>
-          </a:xfrm>
-          <a:prstGeom prst="rect">
-            <a:avLst/>
-          </a:prstGeom>
-          <a:noFill/>
-        </p:spPr>
-        <p:txBody>
-          <a:bodyPr wrap="square">
-            <a:spAutoFit/>
-          </a:bodyPr>
-          <a:lstStyle/>
-          <a:p>
-            <a:pPr>
-              <a:spcAft>
-                <a:spcPts val="800"/>
-              </a:spcAft>
-              <a:defRPr sz="2000" b="1">
-                <a:solidFill>
-                  <a:srgbClr val="FFB02E"/>
-                </a:solidFill>
-              </a:defRPr>
-            </a:pPr>
-            <a:r>
-              <a:t>Paraphrase match</a:t>
-            </a:r>
-          </a:p>
-        </p:txBody>
-      </p:sp>
-      <p:sp>
-        <p:nvSpPr>
-          <p:cNvPr id="14" name="TextBox 13"/>
-          <p:cNvSpPr txBox="1"/>
-          <p:nvPr/>
-        </p:nvSpPr>
-        <p:spPr>
-          <a:xfrm>
-            <a:off x="8321040" y="2331720"/>
-            <a:ext cx="3200400" cy="1371600"/>
-          </a:xfrm>
-          <a:prstGeom prst="rect">
-            <a:avLst/>
-          </a:prstGeom>
-          <a:noFill/>
-        </p:spPr>
-        <p:txBody>
-          <a:bodyPr wrap="square">
-            <a:spAutoFit/>
-          </a:bodyPr>
-          <a:lstStyle/>
-          <a:p>
-            <a:pPr>
-              <a:spcAft>
-                <a:spcPts val="800"/>
-              </a:spcAft>
-              <a:defRPr sz="1500" b="0">
-                <a:solidFill>
-                  <a:srgbClr val="F0F2F8"/>
-                </a:solidFill>
-              </a:defRPr>
-            </a:pPr>
-            <a:r>
-              <a:t>100%</a:t>
-            </a:r>
-          </a:p>
-        </p:txBody>
-      </p:sp>
-      <p:sp>
-        <p:nvSpPr>
-          <p:cNvPr id="15" name="TextBox 14"/>
-          <p:cNvSpPr txBox="1"/>
-          <p:nvPr/>
-        </p:nvSpPr>
-        <p:spPr>
-          <a:xfrm>
-            <a:off x="8321040" y="3063240"/>
-            <a:ext cx="3200400" cy="731520"/>
-          </a:xfrm>
-          <a:prstGeom prst="rect">
-            <a:avLst/>
-          </a:prstGeom>
-          <a:noFill/>
-        </p:spPr>
-        <p:txBody>
-          <a:bodyPr wrap="square">
-            <a:spAutoFit/>
-          </a:bodyPr>
-          <a:lstStyle/>
-          <a:p>
-            <a:pPr>
-              <a:spcAft>
-                <a:spcPts val="800"/>
-              </a:spcAft>
-              <a:defRPr sz="1400" b="0">
-                <a:solidFill>
-                  <a:srgbClr val="969EB0"/>
-                </a:solidFill>
-              </a:defRPr>
-            </a:pPr>
-            <a:r>
-              <a:t>9 / 9 live; 13 / 13 offline eval incl. 2 negative controls</a:t>
+              <a:t>Realme device, real Accessibility events, real STT and TTS.</a:t>
             </a:r>
           </a:p>
         </p:txBody>
       </p:sp>
       <p:pic>
         <p:nvPicPr>
-          <p:cNvPr id="16" name="Picture 15" descr="dash.png"/>
+          <p:cNvPr id="4" name="Picture 3" descr="ph_teach.png"/>
           <p:cNvPicPr>
             <a:picLocks noChangeAspect="1"/>
           </p:cNvPicPr>
@@ -6714,8 +6567,8 @@
         </p:blipFill>
         <p:spPr>
           <a:xfrm>
-            <a:off x="548640" y="3931920"/>
-            <a:ext cx="3394253" cy="2651760"/>
+            <a:off x="822960" y="1554480"/>
+            <a:ext cx="1923936" cy="4297680"/>
           </a:xfrm>
           <a:prstGeom prst="rect">
             <a:avLst/>
@@ -6724,14 +6577,14 @@
       </p:pic>
       <p:sp>
         <p:nvSpPr>
-          <p:cNvPr id="17" name="TextBox 16"/>
+          <p:cNvPr id="5" name="TextBox 4"/>
           <p:cNvSpPr txBox="1"/>
           <p:nvPr/>
         </p:nvSpPr>
         <p:spPr>
           <a:xfrm>
-            <a:off x="4572000" y="4206240"/>
-            <a:ext cx="7132320" cy="1828800"/>
+            <a:off x="822960" y="5943600"/>
+            <a:ext cx="3291840" cy="457200"/>
           </a:xfrm>
           <a:prstGeom prst="rect">
             <a:avLst/>
@@ -6755,7 +6608,131 @@
               </a:defRPr>
             </a:pPr>
             <a:r>
-              <a:t>3 flows: Settings, Calculator, Clock. Small sample, own device: read these as a working proof, not a benchmark.</a:t>
+              <a:t>Teach mode: user demonstrates</a:t>
+            </a:r>
+          </a:p>
+        </p:txBody>
+      </p:sp>
+      <p:pic>
+        <p:nvPicPr>
+          <p:cNvPr id="6" name="Picture 5" descr="ph_replay.png"/>
+          <p:cNvPicPr>
+            <a:picLocks noChangeAspect="1"/>
+          </p:cNvPicPr>
+          <p:nvPr/>
+        </p:nvPicPr>
+        <p:blipFill>
+          <a:blip r:embed="rId3"/>
+          <a:stretch>
+            <a:fillRect/>
+          </a:stretch>
+        </p:blipFill>
+        <p:spPr>
+          <a:xfrm>
+            <a:off x="4572000" y="1554480"/>
+            <a:ext cx="1923936" cy="4297680"/>
+          </a:xfrm>
+          <a:prstGeom prst="rect">
+            <a:avLst/>
+          </a:prstGeom>
+        </p:spPr>
+      </p:pic>
+      <p:sp>
+        <p:nvSpPr>
+          <p:cNvPr id="7" name="TextBox 6"/>
+          <p:cNvSpPr txBox="1"/>
+          <p:nvPr/>
+        </p:nvSpPr>
+        <p:spPr>
+          <a:xfrm>
+            <a:off x="4572000" y="5943600"/>
+            <a:ext cx="3291840" cy="457200"/>
+          </a:xfrm>
+          <a:prstGeom prst="rect">
+            <a:avLst/>
+          </a:prstGeom>
+          <a:noFill/>
+        </p:spPr>
+        <p:txBody>
+          <a:bodyPr wrap="square">
+            <a:spAutoFit/>
+          </a:bodyPr>
+          <a:lstStyle/>
+          <a:p>
+            <a:pPr>
+              <a:spcAft>
+                <a:spcPts val="800"/>
+              </a:spcAft>
+              <a:defRPr sz="1500" b="0">
+                <a:solidFill>
+                  <a:srgbClr val="969EB0"/>
+                </a:solidFill>
+              </a:defRPr>
+            </a:pPr>
+            <a:r>
+              <a:t>New slot, same flow: 9 + 4 = 13</a:t>
+            </a:r>
+          </a:p>
+        </p:txBody>
+      </p:sp>
+      <p:pic>
+        <p:nvPicPr>
+          <p:cNvPr id="8" name="Picture 7" descr="ph_confirm.png"/>
+          <p:cNvPicPr>
+            <a:picLocks noChangeAspect="1"/>
+          </p:cNvPicPr>
+          <p:nvPr/>
+        </p:nvPicPr>
+        <p:blipFill>
+          <a:blip r:embed="rId4"/>
+          <a:stretch>
+            <a:fillRect/>
+          </a:stretch>
+        </p:blipFill>
+        <p:spPr>
+          <a:xfrm>
+            <a:off x="8321040" y="1554480"/>
+            <a:ext cx="1923936" cy="4297680"/>
+          </a:xfrm>
+          <a:prstGeom prst="rect">
+            <a:avLst/>
+          </a:prstGeom>
+        </p:spPr>
+      </p:pic>
+      <p:sp>
+        <p:nvSpPr>
+          <p:cNvPr id="9" name="TextBox 8"/>
+          <p:cNvSpPr txBox="1"/>
+          <p:nvPr/>
+        </p:nvSpPr>
+        <p:spPr>
+          <a:xfrm>
+            <a:off x="8321040" y="5943600"/>
+            <a:ext cx="3291840" cy="457200"/>
+          </a:xfrm>
+          <a:prstGeom prst="rect">
+            <a:avLst/>
+          </a:prstGeom>
+          <a:noFill/>
+        </p:spPr>
+        <p:txBody>
+          <a:bodyPr wrap="square">
+            <a:spAutoFit/>
+          </a:bodyPr>
+          <a:lstStyle/>
+          <a:p>
+            <a:pPr>
+              <a:spcAft>
+                <a:spcPts val="800"/>
+              </a:spcAft>
+              <a:defRPr sz="1500" b="0">
+                <a:solidFill>
+                  <a:srgbClr val="969EB0"/>
+                </a:solidFill>
+              </a:defRPr>
+            </a:pPr>
+            <a:r>
+              <a:t>Confirm before sensitive step</a:t>
             </a:r>
           </a:p>
         </p:txBody>
@@ -6819,21 +6796,59 @@
               </a:defRPr>
             </a:pPr>
             <a:r>
-              <a:t>Safety by design</a:t>
-            </a:r>
-          </a:p>
-        </p:txBody>
-      </p:sp>
-      <p:sp>
-        <p:nvSpPr>
-          <p:cNvPr id="3" name="Rounded Rectangle 2"/>
+              <a:t>Measured results</a:t>
+            </a:r>
+          </a:p>
+        </p:txBody>
+      </p:sp>
+      <p:sp>
+        <p:nvSpPr>
+          <p:cNvPr id="3" name="TextBox 2"/>
+          <p:cNvSpPr txBox="1"/>
+          <p:nvPr/>
+        </p:nvSpPr>
+        <p:spPr>
+          <a:xfrm>
+            <a:off x="548640" y="1097280"/>
+            <a:ext cx="10972800" cy="457200"/>
+          </a:xfrm>
+          <a:prstGeom prst="rect">
+            <a:avLst/>
+          </a:prstGeom>
+          <a:noFill/>
+        </p:spPr>
+        <p:txBody>
+          <a:bodyPr wrap="square">
+            <a:spAutoFit/>
+          </a:bodyPr>
+          <a:lstStyle/>
+          <a:p>
+            <a:pPr>
+              <a:spcAft>
+                <a:spcPts val="800"/>
+              </a:spcAft>
+              <a:defRPr sz="1600" b="0">
+                <a:solidFill>
+                  <a:srgbClr val="969EB0"/>
+                </a:solidFill>
+              </a:defRPr>
+            </a:pPr>
+            <a:r>
+              <a:t>Real phone. Flows and RunLogs reset first. Computed by the dashboard from RunLog data.</a:t>
+            </a:r>
+          </a:p>
+        </p:txBody>
+      </p:sp>
+      <p:sp>
+        <p:nvSpPr>
+          <p:cNvPr id="4" name="Rounded Rectangle 3"/>
           <p:cNvSpPr/>
           <p:nvPr/>
         </p:nvSpPr>
         <p:spPr>
           <a:xfrm>
-            <a:off x="548640" y="1463040"/>
-            <a:ext cx="5394960" cy="4389120"/>
+            <a:off x="548640" y="1645920"/>
+            <a:ext cx="3566160" cy="2194560"/>
           </a:xfrm>
           <a:prstGeom prst="roundRect">
             <a:avLst/>
@@ -6869,14 +6884,14 @@
       </p:sp>
       <p:sp>
         <p:nvSpPr>
-          <p:cNvPr id="4" name="TextBox 3"/>
+          <p:cNvPr id="5" name="TextBox 4"/>
           <p:cNvSpPr txBox="1"/>
           <p:nvPr/>
         </p:nvSpPr>
         <p:spPr>
           <a:xfrm>
-            <a:off x="731520" y="1600200"/>
-            <a:ext cx="5029200" cy="457200"/>
+            <a:off x="731520" y="1783080"/>
+            <a:ext cx="3200400" cy="457200"/>
           </a:xfrm>
           <a:prstGeom prst="rect">
             <a:avLst/>
@@ -6900,21 +6915,21 @@
               </a:defRPr>
             </a:pPr>
             <a:r>
-              <a:t>Never auto-complete</a:t>
-            </a:r>
-          </a:p>
-        </p:txBody>
-      </p:sp>
-      <p:sp>
-        <p:nvSpPr>
-          <p:cNvPr id="5" name="TextBox 4"/>
+              <a:t>Learn success</a:t>
+            </a:r>
+          </a:p>
+        </p:txBody>
+      </p:sp>
+      <p:sp>
+        <p:nvSpPr>
+          <p:cNvPr id="6" name="TextBox 5"/>
           <p:cNvSpPr txBox="1"/>
           <p:nvPr/>
         </p:nvSpPr>
         <p:spPr>
           <a:xfrm>
-            <a:off x="731520" y="2148840"/>
-            <a:ext cx="5029200" cy="3566160"/>
+            <a:off x="731520" y="2331720"/>
+            <a:ext cx="3200400" cy="1371600"/>
           </a:xfrm>
           <a:prstGeom prst="rect">
             <a:avLst/>
@@ -6931,40 +6946,66 @@
               <a:spcAft>
                 <a:spcPts val="800"/>
               </a:spcAft>
-              <a:defRPr sz="1700" b="0">
+              <a:defRPr sz="1500" b="0">
                 <a:solidFill>
                   <a:srgbClr val="F0F2F8"/>
                 </a:solidFill>
               </a:defRPr>
             </a:pPr>
             <a:r>
-              <a:t>Steps that look like pay, send, order, delete are flagged.</a:t>
-            </a:r>
-            <a:br/>
-            <a:r>
-              <a:t>Replay pauses, speaks "Confirm?", waits for Yes or No.</a:t>
-            </a:r>
-            <a:br/>
-            <a:r>
-              <a:t>Unclear answer or no answer = No.</a:t>
-            </a:r>
-            <a:br/>
-            <a:r>
-              <a:t>A declined run is logged as declined, not a failure.</a:t>
-            </a:r>
-          </a:p>
-        </p:txBody>
-      </p:sp>
-      <p:sp>
-        <p:nvSpPr>
-          <p:cNvPr id="6" name="Rounded Rectangle 5"/>
+              <a:t>100%</a:t>
+            </a:r>
+          </a:p>
+        </p:txBody>
+      </p:sp>
+      <p:sp>
+        <p:nvSpPr>
+          <p:cNvPr id="7" name="TextBox 6"/>
+          <p:cNvSpPr txBox="1"/>
+          <p:nvPr/>
+        </p:nvSpPr>
+        <p:spPr>
+          <a:xfrm>
+            <a:off x="731520" y="3063240"/>
+            <a:ext cx="3200400" cy="731520"/>
+          </a:xfrm>
+          <a:prstGeom prst="rect">
+            <a:avLst/>
+          </a:prstGeom>
+          <a:noFill/>
+        </p:spPr>
+        <p:txBody>
+          <a:bodyPr wrap="square">
+            <a:spAutoFit/>
+          </a:bodyPr>
+          <a:lstStyle/>
+          <a:p>
+            <a:pPr>
+              <a:spcAft>
+                <a:spcPts val="800"/>
+              </a:spcAft>
+              <a:defRPr sz="1400" b="0">
+                <a:solidFill>
+                  <a:srgbClr val="969EB0"/>
+                </a:solidFill>
+              </a:defRPr>
+            </a:pPr>
+            <a:r>
+              <a:t>3 / 3 demonstrations turned into flows</a:t>
+            </a:r>
+          </a:p>
+        </p:txBody>
+      </p:sp>
+      <p:sp>
+        <p:nvSpPr>
+          <p:cNvPr id="8" name="Rounded Rectangle 7"/>
           <p:cNvSpPr/>
           <p:nvPr/>
         </p:nvSpPr>
         <p:spPr>
           <a:xfrm>
-            <a:off x="6217920" y="1463040"/>
-            <a:ext cx="5394960" cy="4389120"/>
+            <a:off x="4343400" y="1645920"/>
+            <a:ext cx="3566160" cy="2194560"/>
           </a:xfrm>
           <a:prstGeom prst="roundRect">
             <a:avLst/>
@@ -7000,14 +7041,14 @@
       </p:sp>
       <p:sp>
         <p:nvSpPr>
-          <p:cNvPr id="7" name="TextBox 6"/>
+          <p:cNvPr id="9" name="TextBox 8"/>
           <p:cNvSpPr txBox="1"/>
           <p:nvPr/>
         </p:nvSpPr>
         <p:spPr>
           <a:xfrm>
-            <a:off x="6400800" y="1600200"/>
-            <a:ext cx="5029200" cy="457200"/>
+            <a:off x="4526280" y="1783080"/>
+            <a:ext cx="3200400" cy="457200"/>
           </a:xfrm>
           <a:prstGeom prst="rect">
             <a:avLst/>
@@ -7031,21 +7072,21 @@
               </a:defRPr>
             </a:pPr>
             <a:r>
-              <a:t>Privacy and secrets</a:t>
-            </a:r>
-          </a:p>
-        </p:txBody>
-      </p:sp>
-      <p:sp>
-        <p:nvSpPr>
-          <p:cNvPr id="8" name="TextBox 7"/>
+              <a:t>Replay success</a:t>
+            </a:r>
+          </a:p>
+        </p:txBody>
+      </p:sp>
+      <p:sp>
+        <p:nvSpPr>
+          <p:cNvPr id="10" name="TextBox 9"/>
           <p:cNvSpPr txBox="1"/>
           <p:nvPr/>
         </p:nvSpPr>
         <p:spPr>
           <a:xfrm>
-            <a:off x="6400800" y="2148840"/>
-            <a:ext cx="5029200" cy="3566160"/>
+            <a:off x="4526280" y="2331720"/>
+            <a:ext cx="3200400" cy="1371600"/>
           </a:xfrm>
           <a:prstGeom prst="rect">
             <a:avLst/>
@@ -7062,26 +7103,271 @@
               <a:spcAft>
                 <a:spcPts val="800"/>
               </a:spcAft>
-              <a:defRPr sz="1700" b="0">
+              <a:defRPr sz="1500" b="0">
                 <a:solidFill>
                   <a:srgbClr val="F0F2F8"/>
                 </a:solidFill>
               </a:defRPr>
             </a:pPr>
             <a:r>
-              <a:t>Password / PIN / OTP fields are redacted at record time and never stored or sent to the LLM.</a:t>
-            </a:r>
-            <a:br/>
-            <a:r>
-              <a:t>Keys only via environment; .env gitignored.</a:t>
-            </a:r>
-            <a:br/>
-            <a:r>
-              <a:t>Input validated on every endpoint and WebSocket message.</a:t>
-            </a:r>
-            <a:br/>
-            <a:r>
-              <a:t>Non-root Docker image.</a:t>
+              <a:t>100%</a:t>
+            </a:r>
+          </a:p>
+        </p:txBody>
+      </p:sp>
+      <p:sp>
+        <p:nvSpPr>
+          <p:cNvPr id="11" name="TextBox 10"/>
+          <p:cNvSpPr txBox="1"/>
+          <p:nvPr/>
+        </p:nvSpPr>
+        <p:spPr>
+          <a:xfrm>
+            <a:off x="4526280" y="3063240"/>
+            <a:ext cx="3200400" cy="731520"/>
+          </a:xfrm>
+          <a:prstGeom prst="rect">
+            <a:avLst/>
+          </a:prstGeom>
+          <a:noFill/>
+        </p:spPr>
+        <p:txBody>
+          <a:bodyPr wrap="square">
+            <a:spAutoFit/>
+          </a:bodyPr>
+          <a:lstStyle/>
+          <a:p>
+            <a:pPr>
+              <a:spcAft>
+                <a:spcPts val="800"/>
+              </a:spcAft>
+              <a:defRPr sz="1400" b="0">
+                <a:solidFill>
+                  <a:srgbClr val="969EB0"/>
+                </a:solidFill>
+              </a:defRPr>
+            </a:pPr>
+            <a:r>
+              <a:t>9 / 9 replays with new slot values</a:t>
+            </a:r>
+          </a:p>
+        </p:txBody>
+      </p:sp>
+      <p:sp>
+        <p:nvSpPr>
+          <p:cNvPr id="12" name="Rounded Rectangle 11"/>
+          <p:cNvSpPr/>
+          <p:nvPr/>
+        </p:nvSpPr>
+        <p:spPr>
+          <a:xfrm>
+            <a:off x="8138160" y="1645920"/>
+            <a:ext cx="3566160" cy="2194560"/>
+          </a:xfrm>
+          <a:prstGeom prst="roundRect">
+            <a:avLst/>
+          </a:prstGeom>
+          <a:solidFill>
+            <a:srgbClr val="1F2330"/>
+          </a:solidFill>
+          <a:ln>
+            <a:noFill/>
+          </a:ln>
+        </p:spPr>
+        <p:style>
+          <a:lnRef idx="1">
+            <a:schemeClr val="accent1"/>
+          </a:lnRef>
+          <a:fillRef idx="3">
+            <a:schemeClr val="accent1"/>
+          </a:fillRef>
+          <a:effectRef idx="2">
+            <a:schemeClr val="accent1"/>
+          </a:effectRef>
+          <a:fontRef idx="minor">
+            <a:schemeClr val="lt1"/>
+          </a:fontRef>
+        </p:style>
+        <p:txBody>
+          <a:bodyPr rtlCol="0" anchor="ctr"/>
+          <a:lstStyle/>
+          <a:p>
+            <a:pPr algn="ctr"/>
+          </a:p>
+        </p:txBody>
+      </p:sp>
+      <p:sp>
+        <p:nvSpPr>
+          <p:cNvPr id="13" name="TextBox 12"/>
+          <p:cNvSpPr txBox="1"/>
+          <p:nvPr/>
+        </p:nvSpPr>
+        <p:spPr>
+          <a:xfrm>
+            <a:off x="8321040" y="1783080"/>
+            <a:ext cx="3200400" cy="457200"/>
+          </a:xfrm>
+          <a:prstGeom prst="rect">
+            <a:avLst/>
+          </a:prstGeom>
+          <a:noFill/>
+        </p:spPr>
+        <p:txBody>
+          <a:bodyPr wrap="square">
+            <a:spAutoFit/>
+          </a:bodyPr>
+          <a:lstStyle/>
+          <a:p>
+            <a:pPr>
+              <a:spcAft>
+                <a:spcPts val="800"/>
+              </a:spcAft>
+              <a:defRPr sz="2000" b="1">
+                <a:solidFill>
+                  <a:srgbClr val="FFB02E"/>
+                </a:solidFill>
+              </a:defRPr>
+            </a:pPr>
+            <a:r>
+              <a:t>Paraphrase match</a:t>
+            </a:r>
+          </a:p>
+        </p:txBody>
+      </p:sp>
+      <p:sp>
+        <p:nvSpPr>
+          <p:cNvPr id="14" name="TextBox 13"/>
+          <p:cNvSpPr txBox="1"/>
+          <p:nvPr/>
+        </p:nvSpPr>
+        <p:spPr>
+          <a:xfrm>
+            <a:off x="8321040" y="2331720"/>
+            <a:ext cx="3200400" cy="1371600"/>
+          </a:xfrm>
+          <a:prstGeom prst="rect">
+            <a:avLst/>
+          </a:prstGeom>
+          <a:noFill/>
+        </p:spPr>
+        <p:txBody>
+          <a:bodyPr wrap="square">
+            <a:spAutoFit/>
+          </a:bodyPr>
+          <a:lstStyle/>
+          <a:p>
+            <a:pPr>
+              <a:spcAft>
+                <a:spcPts val="800"/>
+              </a:spcAft>
+              <a:defRPr sz="1500" b="0">
+                <a:solidFill>
+                  <a:srgbClr val="F0F2F8"/>
+                </a:solidFill>
+              </a:defRPr>
+            </a:pPr>
+            <a:r>
+              <a:t>100%</a:t>
+            </a:r>
+          </a:p>
+        </p:txBody>
+      </p:sp>
+      <p:sp>
+        <p:nvSpPr>
+          <p:cNvPr id="15" name="TextBox 14"/>
+          <p:cNvSpPr txBox="1"/>
+          <p:nvPr/>
+        </p:nvSpPr>
+        <p:spPr>
+          <a:xfrm>
+            <a:off x="8321040" y="3063240"/>
+            <a:ext cx="3200400" cy="731520"/>
+          </a:xfrm>
+          <a:prstGeom prst="rect">
+            <a:avLst/>
+          </a:prstGeom>
+          <a:noFill/>
+        </p:spPr>
+        <p:txBody>
+          <a:bodyPr wrap="square">
+            <a:spAutoFit/>
+          </a:bodyPr>
+          <a:lstStyle/>
+          <a:p>
+            <a:pPr>
+              <a:spcAft>
+                <a:spcPts val="800"/>
+              </a:spcAft>
+              <a:defRPr sz="1400" b="0">
+                <a:solidFill>
+                  <a:srgbClr val="969EB0"/>
+                </a:solidFill>
+              </a:defRPr>
+            </a:pPr>
+            <a:r>
+              <a:t>9 / 9 live; 13 / 13 offline eval incl. 2 negative controls</a:t>
+            </a:r>
+          </a:p>
+        </p:txBody>
+      </p:sp>
+      <p:pic>
+        <p:nvPicPr>
+          <p:cNvPr id="16" name="Picture 15" descr="dash.png"/>
+          <p:cNvPicPr>
+            <a:picLocks noChangeAspect="1"/>
+          </p:cNvPicPr>
+          <p:nvPr/>
+        </p:nvPicPr>
+        <p:blipFill>
+          <a:blip r:embed="rId2"/>
+          <a:stretch>
+            <a:fillRect/>
+          </a:stretch>
+        </p:blipFill>
+        <p:spPr>
+          <a:xfrm>
+            <a:off x="548640" y="3931920"/>
+            <a:ext cx="3394253" cy="2651760"/>
+          </a:xfrm>
+          <a:prstGeom prst="rect">
+            <a:avLst/>
+          </a:prstGeom>
+        </p:spPr>
+      </p:pic>
+      <p:sp>
+        <p:nvSpPr>
+          <p:cNvPr id="17" name="TextBox 16"/>
+          <p:cNvSpPr txBox="1"/>
+          <p:nvPr/>
+        </p:nvSpPr>
+        <p:spPr>
+          <a:xfrm>
+            <a:off x="4572000" y="4206240"/>
+            <a:ext cx="7132320" cy="1828800"/>
+          </a:xfrm>
+          <a:prstGeom prst="rect">
+            <a:avLst/>
+          </a:prstGeom>
+          <a:noFill/>
+        </p:spPr>
+        <p:txBody>
+          <a:bodyPr wrap="square">
+            <a:spAutoFit/>
+          </a:bodyPr>
+          <a:lstStyle/>
+          <a:p>
+            <a:pPr>
+              <a:spcAft>
+                <a:spcPts val="800"/>
+              </a:spcAft>
+              <a:defRPr sz="1500" b="0">
+                <a:solidFill>
+                  <a:srgbClr val="969EB0"/>
+                </a:solidFill>
+              </a:defRPr>
+            </a:pPr>
+            <a:r>
+              <a:t>3 flows: Settings, Calculator, Clock. Small sample, own device: read these as a working proof, not a benchmark.</a:t>
             </a:r>
           </a:p>
         </p:txBody>
@@ -7145,21 +7431,64 @@
               </a:defRPr>
             </a:pPr>
             <a:r>
-              <a:t>Limitations, stated plainly</a:t>
-            </a:r>
-          </a:p>
-        </p:txBody>
-      </p:sp>
-      <p:sp>
-        <p:nvSpPr>
-          <p:cNvPr id="3" name="TextBox 2"/>
+              <a:t>Safety by design</a:t>
+            </a:r>
+          </a:p>
+        </p:txBody>
+      </p:sp>
+      <p:sp>
+        <p:nvSpPr>
+          <p:cNvPr id="3" name="Rounded Rectangle 2"/>
+          <p:cNvSpPr/>
+          <p:nvPr/>
+        </p:nvSpPr>
+        <p:spPr>
+          <a:xfrm>
+            <a:off x="548640" y="1463040"/>
+            <a:ext cx="5394960" cy="4389120"/>
+          </a:xfrm>
+          <a:prstGeom prst="roundRect">
+            <a:avLst/>
+          </a:prstGeom>
+          <a:solidFill>
+            <a:srgbClr val="1F2330"/>
+          </a:solidFill>
+          <a:ln>
+            <a:noFill/>
+          </a:ln>
+        </p:spPr>
+        <p:style>
+          <a:lnRef idx="1">
+            <a:schemeClr val="accent1"/>
+          </a:lnRef>
+          <a:fillRef idx="3">
+            <a:schemeClr val="accent1"/>
+          </a:fillRef>
+          <a:effectRef idx="2">
+            <a:schemeClr val="accent1"/>
+          </a:effectRef>
+          <a:fontRef idx="minor">
+            <a:schemeClr val="lt1"/>
+          </a:fontRef>
+        </p:style>
+        <p:txBody>
+          <a:bodyPr rtlCol="0" anchor="ctr"/>
+          <a:lstStyle/>
+          <a:p>
+            <a:pPr algn="ctr"/>
+          </a:p>
+        </p:txBody>
+      </p:sp>
+      <p:sp>
+        <p:nvSpPr>
+          <p:cNvPr id="4" name="TextBox 3"/>
           <p:cNvSpPr txBox="1"/>
           <p:nvPr/>
         </p:nvSpPr>
         <p:spPr>
           <a:xfrm>
-            <a:off x="548640" y="1463040"/>
-            <a:ext cx="10972800" cy="4572000"/>
+            <a:off x="731520" y="1600200"/>
+            <a:ext cx="5029200" cy="457200"/>
           </a:xfrm>
           <a:prstGeom prst="rect">
             <a:avLst/>
@@ -7176,89 +7505,195 @@
               <a:spcAft>
                 <a:spcPts val="800"/>
               </a:spcAft>
-              <a:defRPr sz="1900" b="0">
-                <a:solidFill>
-                  <a:srgbClr val="F0F2F8"/>
+              <a:defRPr sz="2000" b="1">
+                <a:solidFill>
+                  <a:srgbClr val="FFB02E"/>
                 </a:solidFill>
               </a:defRPr>
             </a:pPr>
             <a:r>
-              <a:t>Chrome address-bar suggestion taps emit no accessibility click event, so those flows are hand-authored, not taught.</a:t>
-            </a:r>
-          </a:p>
+              <a:t>Never auto-complete</a:t>
+            </a:r>
+          </a:p>
+        </p:txBody>
+      </p:sp>
+      <p:sp>
+        <p:nvSpPr>
+          <p:cNvPr id="5" name="TextBox 4"/>
+          <p:cNvSpPr txBox="1"/>
+          <p:nvPr/>
+        </p:nvSpPr>
+        <p:spPr>
+          <a:xfrm>
+            <a:off x="731520" y="2148840"/>
+            <a:ext cx="5029200" cy="3566160"/>
+          </a:xfrm>
+          <a:prstGeom prst="rect">
+            <a:avLst/>
+          </a:prstGeom>
+          <a:noFill/>
+        </p:spPr>
+        <p:txBody>
+          <a:bodyPr wrap="square">
+            <a:spAutoFit/>
+          </a:bodyPr>
+          <a:lstStyle/>
           <a:p>
             <a:pPr>
               <a:spcAft>
                 <a:spcPts val="800"/>
               </a:spcAft>
-              <a:defRPr sz="1900" b="0">
+              <a:defRPr sz="1700" b="0">
                 <a:solidFill>
                   <a:srgbClr val="F0F2F8"/>
                 </a:solidFill>
               </a:defRPr>
             </a:pPr>
             <a:r>
-              <a:t>Long-press and drag gestures are not captured yet.</a:t>
-            </a:r>
-          </a:p>
+              <a:t>Steps that look like pay, send, order, delete are flagged.</a:t>
+            </a:r>
+            <a:br/>
+            <a:r>
+              <a:t>Replay pauses, speaks "Confirm?", waits for Yes or No.</a:t>
+            </a:r>
+            <a:br/>
+            <a:r>
+              <a:t>Unclear answer or no answer = No.</a:t>
+            </a:r>
+            <a:br/>
+            <a:r>
+              <a:t>A declined run is logged as declined, not a failure.</a:t>
+            </a:r>
+          </a:p>
+        </p:txBody>
+      </p:sp>
+      <p:sp>
+        <p:nvSpPr>
+          <p:cNvPr id="6" name="Rounded Rectangle 5"/>
+          <p:cNvSpPr/>
+          <p:nvPr/>
+        </p:nvSpPr>
+        <p:spPr>
+          <a:xfrm>
+            <a:off x="6217920" y="1463040"/>
+            <a:ext cx="5394960" cy="4389120"/>
+          </a:xfrm>
+          <a:prstGeom prst="roundRect">
+            <a:avLst/>
+          </a:prstGeom>
+          <a:solidFill>
+            <a:srgbClr val="1F2330"/>
+          </a:solidFill>
+          <a:ln>
+            <a:noFill/>
+          </a:ln>
+        </p:spPr>
+        <p:style>
+          <a:lnRef idx="1">
+            <a:schemeClr val="accent1"/>
+          </a:lnRef>
+          <a:fillRef idx="3">
+            <a:schemeClr val="accent1"/>
+          </a:fillRef>
+          <a:effectRef idx="2">
+            <a:schemeClr val="accent1"/>
+          </a:effectRef>
+          <a:fontRef idx="minor">
+            <a:schemeClr val="lt1"/>
+          </a:fontRef>
+        </p:style>
+        <p:txBody>
+          <a:bodyPr rtlCol="0" anchor="ctr"/>
+          <a:lstStyle/>
+          <a:p>
+            <a:pPr algn="ctr"/>
+          </a:p>
+        </p:txBody>
+      </p:sp>
+      <p:sp>
+        <p:nvSpPr>
+          <p:cNvPr id="7" name="TextBox 6"/>
+          <p:cNvSpPr txBox="1"/>
+          <p:nvPr/>
+        </p:nvSpPr>
+        <p:spPr>
+          <a:xfrm>
+            <a:off x="6400800" y="1600200"/>
+            <a:ext cx="5029200" cy="457200"/>
+          </a:xfrm>
+          <a:prstGeom prst="rect">
+            <a:avLst/>
+          </a:prstGeom>
+          <a:noFill/>
+        </p:spPr>
+        <p:txBody>
+          <a:bodyPr wrap="square">
+            <a:spAutoFit/>
+          </a:bodyPr>
+          <a:lstStyle/>
           <a:p>
             <a:pPr>
               <a:spcAft>
                 <a:spcPts val="800"/>
               </a:spcAft>
-              <a:defRPr sz="1900" b="0">
-                <a:solidFill>
-                  <a:srgbClr val="F0F2F8"/>
+              <a:defRPr sz="2000" b="1">
+                <a:solidFill>
+                  <a:srgbClr val="FFB02E"/>
                 </a:solidFill>
               </a:defRPr>
             </a:pPr>
             <a:r>
-              <a:t>Operators are not slots: "plus" is baked into the taught calculator flow; "9 minus 4" needs its own demo.</a:t>
-            </a:r>
-          </a:p>
+              <a:t>Privacy and secrets</a:t>
+            </a:r>
+          </a:p>
+        </p:txBody>
+      </p:sp>
+      <p:sp>
+        <p:nvSpPr>
+          <p:cNvPr id="8" name="TextBox 7"/>
+          <p:cNvSpPr txBox="1"/>
+          <p:nvPr/>
+        </p:nvSpPr>
+        <p:spPr>
+          <a:xfrm>
+            <a:off x="6400800" y="2148840"/>
+            <a:ext cx="5029200" cy="3566160"/>
+          </a:xfrm>
+          <a:prstGeom prst="rect">
+            <a:avLst/>
+          </a:prstGeom>
+          <a:noFill/>
+        </p:spPr>
+        <p:txBody>
+          <a:bodyPr wrap="square">
+            <a:spAutoFit/>
+          </a:bodyPr>
+          <a:lstStyle/>
           <a:p>
             <a:pPr>
               <a:spcAft>
                 <a:spcPts val="800"/>
               </a:spcAft>
-              <a:defRPr sz="1900" b="0">
+              <a:defRPr sz="1700" b="0">
                 <a:solidFill>
                   <a:srgbClr val="F0F2F8"/>
                 </a:solidFill>
               </a:defRPr>
             </a:pPr>
             <a:r>
-              <a:t>Matching depends on an LLM (openai/gpt-oss-20b on Groq; the Llama model was not available on our key).</a:t>
-            </a:r>
-          </a:p>
-          <a:p>
-            <a:pPr>
-              <a:spcAft>
-                <a:spcPts val="800"/>
-              </a:spcAft>
-              <a:defRPr sz="1900" b="0">
-                <a:solidFill>
-                  <a:srgbClr val="F0F2F8"/>
-                </a:solidFill>
-              </a:defRPr>
-            </a:pPr>
-            <a:r>
-              <a:t>Cleartext LAN/localhost transport for development; production needs TLS.</a:t>
-            </a:r>
-          </a:p>
-          <a:p>
-            <a:pPr>
-              <a:spcAft>
-                <a:spcPts val="800"/>
-              </a:spcAft>
-              <a:defRPr sz="1900" b="0">
-                <a:solidFill>
-                  <a:srgbClr val="F0F2F8"/>
-                </a:solidFill>
-              </a:defRPr>
-            </a:pPr>
-            <a:r>
-              <a:t>Accessibility must be enabled by the user in Settings; Android does not allow it programmatically.</a:t>
+              <a:t>Password / PIN / OTP fields are redacted at record time and never stored or sent to the LLM.</a:t>
+            </a:r>
+            <a:br/>
+            <a:r>
+              <a:t>Keys only via environment; .env gitignored.</a:t>
+            </a:r>
+            <a:br/>
+            <a:r>
+              <a:t>Input validated on every endpoint and WebSocket message.</a:t>
+            </a:r>
+            <a:br/>
+            <a:r>
+              <a:t>Non-root Docker image.</a:t>
             </a:r>
           </a:p>
         </p:txBody>

</xml_diff>

<commit_message>
Deck: fix overflow found by rendering, larger text, real metric numbers
</commit_message>
<xml_diff>
--- a/submission/SRM_University_Kattankulathur_Chennai_Ciphera_s_Presentation.pptx
+++ b/submission/SRM_University_Kattankulathur_Chennai_Ciphera_s_Presentation.pptx
@@ -652,7 +652,7 @@
           <a:lstStyle/>
           <a:p>
             <a:r>
-              <a:t>Be honest: 3 flows, one phone. Two earlier attempts failed while building (slot extraction bug, matcher miss); both fixed and covered by the eval.</a:t>
+              <a:t>Be honest: 3 flows, one phone.</a:t>
             </a:r>
           </a:p>
         </p:txBody>
@@ -3712,8 +3712,8 @@
         </p:nvSpPr>
         <p:spPr>
           <a:xfrm>
-            <a:off x="548640" y="1463040"/>
-            <a:ext cx="10972800" cy="914400"/>
+            <a:off x="548640" y="2194560"/>
+            <a:ext cx="10972800" cy="1371600"/>
           </a:xfrm>
           <a:prstGeom prst="rect">
             <a:avLst/>
@@ -3730,7 +3730,7 @@
               <a:spcAft>
                 <a:spcPts val="800"/>
               </a:spcAft>
-              <a:defRPr sz="2600" b="0">
+              <a:defRPr sz="3600" b="1">
                 <a:solidFill>
                   <a:srgbClr val="F0F2F8"/>
                 </a:solidFill>
@@ -3868,7 +3868,7 @@
         <p:spPr>
           <a:xfrm>
             <a:off x="548640" y="1463040"/>
-            <a:ext cx="10972800" cy="4572000"/>
+            <a:ext cx="10972800" cy="4754880"/>
           </a:xfrm>
           <a:prstGeom prst="rect">
             <a:avLst/>
@@ -3885,7 +3885,7 @@
               <a:spcAft>
                 <a:spcPts val="800"/>
               </a:spcAft>
-              <a:defRPr sz="1900" b="0">
+              <a:defRPr sz="2200" b="0">
                 <a:solidFill>
                   <a:srgbClr val="F0F2F8"/>
                 </a:solidFill>
@@ -3900,7 +3900,7 @@
               <a:spcAft>
                 <a:spcPts val="800"/>
               </a:spcAft>
-              <a:defRPr sz="1900" b="0">
+              <a:defRPr sz="2200" b="0">
                 <a:solidFill>
                   <a:srgbClr val="F0F2F8"/>
                 </a:solidFill>
@@ -3915,7 +3915,7 @@
               <a:spcAft>
                 <a:spcPts val="800"/>
               </a:spcAft>
-              <a:defRPr sz="1900" b="0">
+              <a:defRPr sz="2200" b="0">
                 <a:solidFill>
                   <a:srgbClr val="F0F2F8"/>
                 </a:solidFill>
@@ -3930,7 +3930,7 @@
               <a:spcAft>
                 <a:spcPts val="800"/>
               </a:spcAft>
-              <a:defRPr sz="1900" b="0">
+              <a:defRPr sz="2200" b="0">
                 <a:solidFill>
                   <a:srgbClr val="F0F2F8"/>
                 </a:solidFill>
@@ -3945,7 +3945,7 @@
               <a:spcAft>
                 <a:spcPts val="800"/>
               </a:spcAft>
-              <a:defRPr sz="1900" b="0">
+              <a:defRPr sz="2200" b="0">
                 <a:solidFill>
                   <a:srgbClr val="F0F2F8"/>
                 </a:solidFill>
@@ -3960,7 +3960,7 @@
               <a:spcAft>
                 <a:spcPts val="800"/>
               </a:spcAft>
-              <a:defRPr sz="1900" b="0">
+              <a:defRPr sz="2200" b="0">
                 <a:solidFill>
                   <a:srgbClr val="F0F2F8"/>
                 </a:solidFill>
@@ -4143,7 +4143,7 @@
               <a:spcAft>
                 <a:spcPts val="800"/>
               </a:spcAft>
-              <a:defRPr sz="2000" b="1">
+              <a:defRPr sz="2400" b="1">
                 <a:solidFill>
                   <a:srgbClr val="FFB02E"/>
                 </a:solidFill>
@@ -4181,7 +4181,7 @@
               <a:spcAft>
                 <a:spcPts val="800"/>
               </a:spcAft>
-              <a:defRPr sz="1500" b="0">
+              <a:defRPr sz="2000" b="0">
                 <a:solidFill>
                   <a:srgbClr val="F0F2F8"/>
                 </a:solidFill>
@@ -4262,7 +4262,7 @@
               <a:spcAft>
                 <a:spcPts val="800"/>
               </a:spcAft>
-              <a:defRPr sz="2000" b="1">
+              <a:defRPr sz="2400" b="1">
                 <a:solidFill>
                   <a:srgbClr val="FFB02E"/>
                 </a:solidFill>
@@ -4300,7 +4300,7 @@
               <a:spcAft>
                 <a:spcPts val="800"/>
               </a:spcAft>
-              <a:defRPr sz="1500" b="0">
+              <a:defRPr sz="2000" b="0">
                 <a:solidFill>
                   <a:srgbClr val="F0F2F8"/>
                 </a:solidFill>
@@ -4381,7 +4381,7 @@
               <a:spcAft>
                 <a:spcPts val="800"/>
               </a:spcAft>
-              <a:defRPr sz="2000" b="1">
+              <a:defRPr sz="2400" b="1">
                 <a:solidFill>
                   <a:srgbClr val="FFB02E"/>
                 </a:solidFill>
@@ -4419,7 +4419,7 @@
               <a:spcAft>
                 <a:spcPts val="800"/>
               </a:spcAft>
-              <a:defRPr sz="1500" b="0">
+              <a:defRPr sz="2000" b="0">
                 <a:solidFill>
                   <a:srgbClr val="F0F2F8"/>
                 </a:solidFill>
@@ -4602,7 +4602,7 @@
               <a:spcAft>
                 <a:spcPts val="800"/>
               </a:spcAft>
-              <a:defRPr sz="2000" b="1">
+              <a:defRPr sz="2400" b="1">
                 <a:solidFill>
                   <a:srgbClr val="FFB02E"/>
                 </a:solidFill>
@@ -4640,7 +4640,7 @@
               <a:spcAft>
                 <a:spcPts val="800"/>
               </a:spcAft>
-              <a:defRPr sz="1500" b="0">
+              <a:defRPr sz="2000" b="0">
                 <a:solidFill>
                   <a:srgbClr val="F0F2F8"/>
                 </a:solidFill>
@@ -4721,7 +4721,7 @@
               <a:spcAft>
                 <a:spcPts val="800"/>
               </a:spcAft>
-              <a:defRPr sz="2000" b="1">
+              <a:defRPr sz="2400" b="1">
                 <a:solidFill>
                   <a:srgbClr val="FFB02E"/>
                 </a:solidFill>
@@ -4759,7 +4759,7 @@
               <a:spcAft>
                 <a:spcPts val="800"/>
               </a:spcAft>
-              <a:defRPr sz="1500" b="0">
+              <a:defRPr sz="2000" b="0">
                 <a:solidFill>
                   <a:srgbClr val="F0F2F8"/>
                 </a:solidFill>
@@ -4840,7 +4840,7 @@
               <a:spcAft>
                 <a:spcPts val="800"/>
               </a:spcAft>
-              <a:defRPr sz="2000" b="1">
+              <a:defRPr sz="2400" b="1">
                 <a:solidFill>
                   <a:srgbClr val="FFB02E"/>
                 </a:solidFill>
@@ -4878,7 +4878,7 @@
               <a:spcAft>
                 <a:spcPts val="800"/>
               </a:spcAft>
-              <a:defRPr sz="1500" b="0">
+              <a:defRPr sz="2000" b="0">
                 <a:solidFill>
                   <a:srgbClr val="F0F2F8"/>
                 </a:solidFill>
@@ -5061,7 +5061,7 @@
               <a:spcAft>
                 <a:spcPts val="800"/>
               </a:spcAft>
-              <a:defRPr sz="2000" b="1">
+              <a:defRPr sz="2400" b="1">
                 <a:solidFill>
                   <a:srgbClr val="FFB02E"/>
                 </a:solidFill>
@@ -5099,7 +5099,7 @@
               <a:spcAft>
                 <a:spcPts val="800"/>
               </a:spcAft>
-              <a:defRPr sz="1500" b="0">
+              <a:defRPr sz="2000" b="0">
                 <a:solidFill>
                   <a:srgbClr val="F0F2F8"/>
                 </a:solidFill>
@@ -5180,7 +5180,7 @@
               <a:spcAft>
                 <a:spcPts val="800"/>
               </a:spcAft>
-              <a:defRPr sz="2000" b="1">
+              <a:defRPr sz="2400" b="1">
                 <a:solidFill>
                   <a:srgbClr val="FFB02E"/>
                 </a:solidFill>
@@ -5218,7 +5218,7 @@
               <a:spcAft>
                 <a:spcPts val="800"/>
               </a:spcAft>
-              <a:defRPr sz="1500" b="0">
+              <a:defRPr sz="2000" b="0">
                 <a:solidFill>
                   <a:srgbClr val="F0F2F8"/>
                 </a:solidFill>
@@ -5299,7 +5299,7 @@
               <a:spcAft>
                 <a:spcPts val="800"/>
               </a:spcAft>
-              <a:defRPr sz="2000" b="1">
+              <a:defRPr sz="2400" b="1">
                 <a:solidFill>
                   <a:srgbClr val="FFB02E"/>
                 </a:solidFill>
@@ -5337,7 +5337,7 @@
               <a:spcAft>
                 <a:spcPts val="800"/>
               </a:spcAft>
-              <a:defRPr sz="1500" b="0">
+              <a:defRPr sz="2000" b="0">
                 <a:solidFill>
                   <a:srgbClr val="F0F2F8"/>
                 </a:solidFill>
@@ -5582,7 +5582,7 @@
               <a:spcAft>
                 <a:spcPts val="800"/>
               </a:spcAft>
-              <a:defRPr sz="2000" b="1">
+              <a:defRPr sz="2400" b="1">
                 <a:solidFill>
                   <a:srgbClr val="FFB02E"/>
                 </a:solidFill>
@@ -5620,7 +5620,7 @@
               <a:spcAft>
                 <a:spcPts val="800"/>
               </a:spcAft>
-              <a:defRPr sz="1700" b="0">
+              <a:defRPr sz="2200" b="0">
                 <a:solidFill>
                   <a:srgbClr val="F0F2F8"/>
                 </a:solidFill>
@@ -5701,7 +5701,7 @@
               <a:spcAft>
                 <a:spcPts val="800"/>
               </a:spcAft>
-              <a:defRPr sz="2000" b="1">
+              <a:defRPr sz="2400" b="1">
                 <a:solidFill>
                   <a:srgbClr val="FFB02E"/>
                 </a:solidFill>
@@ -5739,7 +5739,7 @@
               <a:spcAft>
                 <a:spcPts val="800"/>
               </a:spcAft>
-              <a:defRPr sz="1700" b="0">
+              <a:defRPr sz="2200" b="0">
                 <a:solidFill>
                   <a:srgbClr val="F0F2F8"/>
                 </a:solidFill>
@@ -5922,7 +5922,7 @@
               <a:spcAft>
                 <a:spcPts val="800"/>
               </a:spcAft>
-              <a:defRPr sz="2000" b="1">
+              <a:defRPr sz="2400" b="1">
                 <a:solidFill>
                   <a:srgbClr val="FFB02E"/>
                 </a:solidFill>
@@ -5960,7 +5960,7 @@
               <a:spcAft>
                 <a:spcPts val="800"/>
               </a:spcAft>
-              <a:defRPr sz="1500" b="0">
+              <a:defRPr sz="2000" b="0">
                 <a:solidFill>
                   <a:srgbClr val="F0F2F8"/>
                 </a:solidFill>
@@ -6057,14 +6057,14 @@
               <a:spcAft>
                 <a:spcPts val="800"/>
               </a:spcAft>
-              <a:defRPr sz="2000" b="1">
+              <a:defRPr sz="2400" b="1">
                 <a:solidFill>
                   <a:srgbClr val="FFB02E"/>
                 </a:solidFill>
               </a:defRPr>
             </a:pPr>
             <a:r>
-              <a:t>Backend (Node, Express, Mongo, Docker)</a:t>
+              <a:t>Backend (Node + Mongo)</a:t>
             </a:r>
           </a:p>
         </p:txBody>
@@ -6095,7 +6095,7 @@
               <a:spcAft>
                 <a:spcPts val="800"/>
               </a:spcAft>
-              <a:defRPr sz="1500" b="0">
+              <a:defRPr sz="2000" b="0">
                 <a:solidFill>
                   <a:srgbClr val="F0F2F8"/>
                 </a:solidFill>
@@ -6260,7 +6260,7 @@
               <a:spcAft>
                 <a:spcPts val="800"/>
               </a:spcAft>
-              <a:defRPr sz="2000" b="1">
+              <a:defRPr sz="2400" b="1">
                 <a:solidFill>
                   <a:srgbClr val="FFB02E"/>
                 </a:solidFill>
@@ -6298,7 +6298,7 @@
               <a:spcAft>
                 <a:spcPts val="800"/>
               </a:spcAft>
-              <a:defRPr sz="1700" b="0">
+              <a:defRPr sz="2200" b="0">
                 <a:solidFill>
                   <a:srgbClr val="F0F2F8"/>
                 </a:solidFill>
@@ -6387,7 +6387,7 @@
               <a:spcAft>
                 <a:spcPts val="800"/>
               </a:spcAft>
-              <a:defRPr sz="2000" b="1">
+              <a:defRPr sz="2400" b="1">
                 <a:solidFill>
                   <a:srgbClr val="FFB02E"/>
                 </a:solidFill>
@@ -6425,7 +6425,7 @@
               <a:spcAft>
                 <a:spcPts val="800"/>
               </a:spcAft>
-              <a:defRPr sz="1700" b="0">
+              <a:defRPr sz="2200" b="0">
                 <a:solidFill>
                   <a:srgbClr val="F0F2F8"/>
                 </a:solidFill>
@@ -6847,8 +6847,8 @@
         </p:nvSpPr>
         <p:spPr>
           <a:xfrm>
-            <a:off x="548640" y="1645920"/>
-            <a:ext cx="3566160" cy="2194560"/>
+            <a:off x="548640" y="1554480"/>
+            <a:ext cx="3566160" cy="2103120"/>
           </a:xfrm>
           <a:prstGeom prst="roundRect">
             <a:avLst/>
@@ -6890,7 +6890,7 @@
         </p:nvSpPr>
         <p:spPr>
           <a:xfrm>
-            <a:off x="731520" y="1783080"/>
+            <a:off x="731520" y="1645920"/>
             <a:ext cx="3200400" cy="457200"/>
           </a:xfrm>
           <a:prstGeom prst="rect">
@@ -6908,9 +6908,9 @@
               <a:spcAft>
                 <a:spcPts val="800"/>
               </a:spcAft>
-              <a:defRPr sz="2000" b="1">
-                <a:solidFill>
-                  <a:srgbClr val="FFB02E"/>
+              <a:defRPr sz="2000" b="0">
+                <a:solidFill>
+                  <a:srgbClr val="969EB0"/>
                 </a:solidFill>
               </a:defRPr>
             </a:pPr>
@@ -6928,8 +6928,8 @@
         </p:nvSpPr>
         <p:spPr>
           <a:xfrm>
-            <a:off x="731520" y="2331720"/>
-            <a:ext cx="3200400" cy="1371600"/>
+            <a:off x="731520" y="2011680"/>
+            <a:ext cx="3200400" cy="914400"/>
           </a:xfrm>
           <a:prstGeom prst="rect">
             <a:avLst/>
@@ -6946,9 +6946,9 @@
               <a:spcAft>
                 <a:spcPts val="800"/>
               </a:spcAft>
-              <a:defRPr sz="1500" b="0">
-                <a:solidFill>
-                  <a:srgbClr val="F0F2F8"/>
+              <a:defRPr sz="5400" b="1">
+                <a:solidFill>
+                  <a:srgbClr val="FFB02E"/>
                 </a:solidFill>
               </a:defRPr>
             </a:pPr>
@@ -6966,7 +6966,7 @@
         </p:nvSpPr>
         <p:spPr>
           <a:xfrm>
-            <a:off x="731520" y="3063240"/>
+            <a:off x="731520" y="2926080"/>
             <a:ext cx="3200400" cy="731520"/>
           </a:xfrm>
           <a:prstGeom prst="rect">
@@ -7004,8 +7004,8 @@
         </p:nvSpPr>
         <p:spPr>
           <a:xfrm>
-            <a:off x="4343400" y="1645920"/>
-            <a:ext cx="3566160" cy="2194560"/>
+            <a:off x="4343400" y="1554480"/>
+            <a:ext cx="3566160" cy="2103120"/>
           </a:xfrm>
           <a:prstGeom prst="roundRect">
             <a:avLst/>
@@ -7047,7 +7047,7 @@
         </p:nvSpPr>
         <p:spPr>
           <a:xfrm>
-            <a:off x="4526280" y="1783080"/>
+            <a:off x="4526280" y="1645920"/>
             <a:ext cx="3200400" cy="457200"/>
           </a:xfrm>
           <a:prstGeom prst="rect">
@@ -7065,9 +7065,9 @@
               <a:spcAft>
                 <a:spcPts val="800"/>
               </a:spcAft>
-              <a:defRPr sz="2000" b="1">
-                <a:solidFill>
-                  <a:srgbClr val="FFB02E"/>
+              <a:defRPr sz="2000" b="0">
+                <a:solidFill>
+                  <a:srgbClr val="969EB0"/>
                 </a:solidFill>
               </a:defRPr>
             </a:pPr>
@@ -7085,8 +7085,8 @@
         </p:nvSpPr>
         <p:spPr>
           <a:xfrm>
-            <a:off x="4526280" y="2331720"/>
-            <a:ext cx="3200400" cy="1371600"/>
+            <a:off x="4526280" y="2011680"/>
+            <a:ext cx="3200400" cy="914400"/>
           </a:xfrm>
           <a:prstGeom prst="rect">
             <a:avLst/>
@@ -7103,9 +7103,9 @@
               <a:spcAft>
                 <a:spcPts val="800"/>
               </a:spcAft>
-              <a:defRPr sz="1500" b="0">
-                <a:solidFill>
-                  <a:srgbClr val="F0F2F8"/>
+              <a:defRPr sz="5400" b="1">
+                <a:solidFill>
+                  <a:srgbClr val="FFB02E"/>
                 </a:solidFill>
               </a:defRPr>
             </a:pPr>
@@ -7123,7 +7123,7 @@
         </p:nvSpPr>
         <p:spPr>
           <a:xfrm>
-            <a:off x="4526280" y="3063240"/>
+            <a:off x="4526280" y="2926080"/>
             <a:ext cx="3200400" cy="731520"/>
           </a:xfrm>
           <a:prstGeom prst="rect">
@@ -7161,8 +7161,8 @@
         </p:nvSpPr>
         <p:spPr>
           <a:xfrm>
-            <a:off x="8138160" y="1645920"/>
-            <a:ext cx="3566160" cy="2194560"/>
+            <a:off x="8138160" y="1554480"/>
+            <a:ext cx="3566160" cy="2103120"/>
           </a:xfrm>
           <a:prstGeom prst="roundRect">
             <a:avLst/>
@@ -7204,7 +7204,7 @@
         </p:nvSpPr>
         <p:spPr>
           <a:xfrm>
-            <a:off x="8321040" y="1783080"/>
+            <a:off x="8321040" y="1645920"/>
             <a:ext cx="3200400" cy="457200"/>
           </a:xfrm>
           <a:prstGeom prst="rect">
@@ -7222,9 +7222,9 @@
               <a:spcAft>
                 <a:spcPts val="800"/>
               </a:spcAft>
-              <a:defRPr sz="2000" b="1">
-                <a:solidFill>
-                  <a:srgbClr val="FFB02E"/>
+              <a:defRPr sz="2000" b="0">
+                <a:solidFill>
+                  <a:srgbClr val="969EB0"/>
                 </a:solidFill>
               </a:defRPr>
             </a:pPr>
@@ -7242,8 +7242,8 @@
         </p:nvSpPr>
         <p:spPr>
           <a:xfrm>
-            <a:off x="8321040" y="2331720"/>
-            <a:ext cx="3200400" cy="1371600"/>
+            <a:off x="8321040" y="2011680"/>
+            <a:ext cx="3200400" cy="914400"/>
           </a:xfrm>
           <a:prstGeom prst="rect">
             <a:avLst/>
@@ -7260,9 +7260,9 @@
               <a:spcAft>
                 <a:spcPts val="800"/>
               </a:spcAft>
-              <a:defRPr sz="1500" b="0">
-                <a:solidFill>
-                  <a:srgbClr val="F0F2F8"/>
+              <a:defRPr sz="5400" b="1">
+                <a:solidFill>
+                  <a:srgbClr val="FFB02E"/>
                 </a:solidFill>
               </a:defRPr>
             </a:pPr>
@@ -7280,7 +7280,7 @@
         </p:nvSpPr>
         <p:spPr>
           <a:xfrm>
-            <a:off x="8321040" y="3063240"/>
+            <a:off x="8321040" y="2926080"/>
             <a:ext cx="3200400" cy="731520"/>
           </a:xfrm>
           <a:prstGeom prst="rect">
@@ -7312,7 +7312,7 @@
       </p:sp>
       <p:pic>
         <p:nvPicPr>
-          <p:cNvPr id="16" name="Picture 15" descr="dash.png"/>
+          <p:cNvPr id="16" name="Picture 15" descr="dash_top.png"/>
           <p:cNvPicPr>
             <a:picLocks noChangeAspect="1"/>
           </p:cNvPicPr>
@@ -7326,8 +7326,8 @@
         </p:blipFill>
         <p:spPr>
           <a:xfrm>
-            <a:off x="548640" y="3931920"/>
-            <a:ext cx="3394253" cy="2651760"/>
+            <a:off x="548640" y="3840480"/>
+            <a:ext cx="5434149" cy="2377440"/>
           </a:xfrm>
           <a:prstGeom prst="rect">
             <a:avLst/>
@@ -7342,8 +7342,8 @@
         </p:nvSpPr>
         <p:spPr>
           <a:xfrm>
-            <a:off x="4572000" y="4206240"/>
-            <a:ext cx="7132320" cy="1828800"/>
+            <a:off x="5852160" y="4023360"/>
+            <a:ext cx="5852160" cy="2194560"/>
           </a:xfrm>
           <a:prstGeom prst="rect">
             <a:avLst/>
@@ -7360,14 +7360,44 @@
               <a:spcAft>
                 <a:spcPts val="800"/>
               </a:spcAft>
-              <a:defRPr sz="1500" b="0">
-                <a:solidFill>
-                  <a:srgbClr val="969EB0"/>
+              <a:defRPr sz="1800" b="0">
+                <a:solidFill>
+                  <a:srgbClr val="F0F2F8"/>
                 </a:solidFill>
               </a:defRPr>
             </a:pPr>
             <a:r>
-              <a:t>3 flows: Settings, Calculator, Clock. Small sample, own device: read these as a working proof, not a benchmark.</a:t>
+              <a:t>3 flows: Settings, Calculator, Clock.</a:t>
+            </a:r>
+          </a:p>
+          <a:p>
+            <a:pPr>
+              <a:spcAft>
+                <a:spcPts val="800"/>
+              </a:spcAft>
+              <a:defRPr sz="1800" b="0">
+                <a:solidFill>
+                  <a:srgbClr val="F0F2F8"/>
+                </a:solidFill>
+              </a:defRPr>
+            </a:pPr>
+            <a:r>
+              <a:t>Small sample on one phone: read this as a working proof, not a benchmark.</a:t>
+            </a:r>
+          </a:p>
+          <a:p>
+            <a:pPr>
+              <a:spcAft>
+                <a:spcPts val="800"/>
+              </a:spcAft>
+              <a:defRPr sz="1800" b="0">
+                <a:solidFill>
+                  <a:srgbClr val="F0F2F8"/>
+                </a:solidFill>
+              </a:defRPr>
+            </a:pPr>
+            <a:r>
+              <a:t>Earlier attempts that failed while building were fixed and are covered by the offline eval.</a:t>
             </a:r>
           </a:p>
         </p:txBody>
@@ -7505,7 +7535,7 @@
               <a:spcAft>
                 <a:spcPts val="800"/>
               </a:spcAft>
-              <a:defRPr sz="2000" b="1">
+              <a:defRPr sz="2400" b="1">
                 <a:solidFill>
                   <a:srgbClr val="FFB02E"/>
                 </a:solidFill>
@@ -7543,7 +7573,7 @@
               <a:spcAft>
                 <a:spcPts val="800"/>
               </a:spcAft>
-              <a:defRPr sz="1700" b="0">
+              <a:defRPr sz="2200" b="0">
                 <a:solidFill>
                   <a:srgbClr val="F0F2F8"/>
                 </a:solidFill>
@@ -7636,7 +7666,7 @@
               <a:spcAft>
                 <a:spcPts val="800"/>
               </a:spcAft>
-              <a:defRPr sz="2000" b="1">
+              <a:defRPr sz="2400" b="1">
                 <a:solidFill>
                   <a:srgbClr val="FFB02E"/>
                 </a:solidFill>
@@ -7674,7 +7704,7 @@
               <a:spcAft>
                 <a:spcPts val="800"/>
               </a:spcAft>
-              <a:defRPr sz="1700" b="0">
+              <a:defRPr sz="2200" b="0">
                 <a:solidFill>
                   <a:srgbClr val="F0F2F8"/>
                 </a:solidFill>

</xml_diff>

<commit_message>
Final submission: architecture diagram in deck, demo video, Theme 3 PDF, requirements.txt, LICENSE; drop internal working docs
</commit_message>
<xml_diff>
--- a/submission/SRM_University_Kattankulathur_Chennai_Ciphera_s_Presentation.pptx
+++ b/submission/SRM_University_Kattankulathur_Chennai_Ciphera_s_Presentation.pptx
@@ -5785,8 +5785,8 @@
         </p:nvSpPr>
         <p:spPr>
           <a:xfrm>
-            <a:off x="548640" y="365760"/>
-            <a:ext cx="10972800" cy="822960"/>
+            <a:off x="548640" y="310896"/>
+            <a:ext cx="10881360" cy="731520"/>
           </a:xfrm>
           <a:prstGeom prst="rect">
             <a:avLst/>
@@ -5794,22 +5794,25 @@
           <a:noFill/>
         </p:spPr>
         <p:txBody>
-          <a:bodyPr wrap="square">
+          <a:bodyPr wrap="square" anchor="t" lIns="73152" rIns="73152" tIns="27432" bIns="27432">
             <a:spAutoFit/>
           </a:bodyPr>
           <a:lstStyle/>
           <a:p>
-            <a:pPr>
-              <a:spcAft>
-                <a:spcPts val="800"/>
-              </a:spcAft>
-              <a:defRPr sz="3400" b="1">
+            <a:pPr algn="l">
+              <a:spcBef>
+                <a:spcPts val="0"/>
+              </a:spcBef>
+              <a:spcAft>
+                <a:spcPts val="100"/>
+              </a:spcAft>
+            </a:pPr>
+            <a:r>
+              <a:rPr sz="3400" b="1">
                 <a:solidFill>
                   <a:srgbClr val="FFB02E"/>
                 </a:solidFill>
-              </a:defRPr>
-            </a:pPr>
-            <a:r>
+              </a:rPr>
               <a:t>Architecture</a:t>
             </a:r>
           </a:p>
@@ -5823,8 +5826,8 @@
         </p:nvSpPr>
         <p:spPr>
           <a:xfrm>
-            <a:off x="548640" y="1097280"/>
-            <a:ext cx="10972800" cy="457200"/>
+            <a:off x="548640" y="1024128"/>
+            <a:ext cx="10881360" cy="457200"/>
           </a:xfrm>
           <a:prstGeom prst="rect">
             <a:avLst/>
@@ -5832,23 +5835,26 @@
           <a:noFill/>
         </p:spPr>
         <p:txBody>
-          <a:bodyPr wrap="square">
+          <a:bodyPr wrap="square" anchor="t" lIns="73152" rIns="73152" tIns="27432" bIns="27432">
             <a:spAutoFit/>
           </a:bodyPr>
           <a:lstStyle/>
           <a:p>
-            <a:pPr>
-              <a:spcAft>
-                <a:spcPts val="800"/>
-              </a:spcAft>
-              <a:defRPr sz="1600" b="0">
+            <a:pPr algn="l">
+              <a:spcBef>
+                <a:spcPts val="0"/>
+              </a:spcBef>
+              <a:spcAft>
+                <a:spcPts val="100"/>
+              </a:spcAft>
+            </a:pPr>
+            <a:r>
+              <a:rPr sz="1600" b="0">
                 <a:solidFill>
                   <a:srgbClr val="969EB0"/>
                 </a:solidFill>
-              </a:defRPr>
-            </a:pPr>
-            <a:r>
-              <a:t>Android does the acting. The backend does the understanding.</a:t>
+              </a:rPr>
+              <a:t>One WebSocket link: the phone acts through Accessibility, the backend understands with STT and an LLM.</a:t>
             </a:r>
           </a:p>
         </p:txBody>
@@ -5861,18 +5867,23 @@
         </p:nvSpPr>
         <p:spPr>
           <a:xfrm>
-            <a:off x="548640" y="1645920"/>
-            <a:ext cx="5486400" cy="4206240"/>
+            <a:off x="502920" y="1517904"/>
+            <a:ext cx="4846320" cy="3163824"/>
           </a:xfrm>
           <a:prstGeom prst="roundRect">
-            <a:avLst/>
+            <a:avLst>
+              <a:gd name="adj" fmla="val 4500"/>
+            </a:avLst>
           </a:prstGeom>
           <a:solidFill>
-            <a:srgbClr val="1F2330"/>
+            <a:srgbClr val="1B1F2B"/>
           </a:solidFill>
-          <a:ln>
-            <a:noFill/>
+          <a:ln w="12700">
+            <a:solidFill>
+              <a:srgbClr val="3C4763"/>
+            </a:solidFill>
           </a:ln>
+          <a:effectLst/>
         </p:spPr>
         <p:style>
           <a:lnRef idx="1">
@@ -5898,116 +5909,29 @@
       </p:sp>
       <p:sp>
         <p:nvSpPr>
-          <p:cNvPr id="5" name="TextBox 4"/>
-          <p:cNvSpPr txBox="1"/>
-          <p:nvPr/>
-        </p:nvSpPr>
-        <p:spPr>
-          <a:xfrm>
-            <a:off x="731520" y="1783080"/>
-            <a:ext cx="5120640" cy="457200"/>
-          </a:xfrm>
-          <a:prstGeom prst="rect">
-            <a:avLst/>
-          </a:prstGeom>
-          <a:noFill/>
-        </p:spPr>
-        <p:txBody>
-          <a:bodyPr wrap="square">
-            <a:spAutoFit/>
-          </a:bodyPr>
-          <a:lstStyle/>
-          <a:p>
-            <a:pPr>
-              <a:spcAft>
-                <a:spcPts val="800"/>
-              </a:spcAft>
-              <a:defRPr sz="2400" b="1">
-                <a:solidFill>
-                  <a:srgbClr val="FFB02E"/>
-                </a:solidFill>
-              </a:defRPr>
-            </a:pPr>
-            <a:r>
-              <a:t>Android (Kotlin)</a:t>
-            </a:r>
-          </a:p>
-        </p:txBody>
-      </p:sp>
-      <p:sp>
-        <p:nvSpPr>
-          <p:cNvPr id="6" name="TextBox 5"/>
-          <p:cNvSpPr txBox="1"/>
-          <p:nvPr/>
-        </p:nvSpPr>
-        <p:spPr>
-          <a:xfrm>
-            <a:off x="731520" y="2331720"/>
-            <a:ext cx="5120640" cy="3383279"/>
-          </a:xfrm>
-          <a:prstGeom prst="rect">
-            <a:avLst/>
-          </a:prstGeom>
-          <a:noFill/>
-        </p:spPr>
-        <p:txBody>
-          <a:bodyPr wrap="square">
-            <a:spAutoFit/>
-          </a:bodyPr>
-          <a:lstStyle/>
-          <a:p>
-            <a:pPr>
-              <a:spcAft>
-                <a:spcPts val="800"/>
-              </a:spcAft>
-              <a:defRPr sz="2000" b="0">
-                <a:solidFill>
-                  <a:srgbClr val="F0F2F8"/>
-                </a:solidFill>
-              </a:defRPr>
-            </a:pPr>
-            <a:r>
-              <a:t>AccessibilityService: read UI tree, tap, type, scroll, back</a:t>
-            </a:r>
-            <a:br/>
-            <a:r>
-              <a:t>Flow Recorder: events to selectors, passwords redacted</a:t>
-            </a:r>
-            <a:br/>
-            <a:r>
-              <a:t>Flow Replayer: resourceId &gt; text &gt; desc &gt; class, 6 s wait, retry, LLM fallback</a:t>
-            </a:r>
-            <a:br/>
-            <a:r>
-              <a:t>Overlay: draggable mic, TEACH MODE indicator, Yes/No</a:t>
-            </a:r>
-            <a:br/>
-            <a:r>
-              <a:t>Foreground service: push-to-talk audio, WebSocket, TTS playback</a:t>
-            </a:r>
-          </a:p>
-        </p:txBody>
-      </p:sp>
-      <p:sp>
-        <p:nvSpPr>
-          <p:cNvPr id="7" name="Rounded Rectangle 6"/>
+          <p:cNvPr id="5" name="Rounded Rectangle 4"/>
           <p:cNvSpPr/>
           <p:nvPr/>
         </p:nvSpPr>
         <p:spPr>
           <a:xfrm>
-            <a:off x="6217920" y="1645920"/>
-            <a:ext cx="5486400" cy="4206240"/>
+            <a:off x="6839712" y="1517904"/>
+            <a:ext cx="4846320" cy="3163824"/>
           </a:xfrm>
           <a:prstGeom prst="roundRect">
-            <a:avLst/>
+            <a:avLst>
+              <a:gd name="adj" fmla="val 4500"/>
+            </a:avLst>
           </a:prstGeom>
           <a:solidFill>
-            <a:srgbClr val="1F2330"/>
+            <a:srgbClr val="1B1F2B"/>
           </a:solidFill>
-          <a:ln>
-            <a:noFill/>
+          <a:ln w="12700">
+            <a:solidFill>
+              <a:srgbClr val="3C4763"/>
+            </a:solidFill>
           </a:ln>
+          <a:effectLst/>
         </p:spPr>
         <p:style>
           <a:lnRef idx="1">
@@ -6033,14 +5957,14 @@
       </p:sp>
       <p:sp>
         <p:nvSpPr>
-          <p:cNvPr id="8" name="TextBox 7"/>
+          <p:cNvPr id="6" name="TextBox 5"/>
           <p:cNvSpPr txBox="1"/>
           <p:nvPr/>
         </p:nvSpPr>
         <p:spPr>
           <a:xfrm>
-            <a:off x="6400800" y="1783080"/>
-            <a:ext cx="5120640" cy="457200"/>
+            <a:off x="704088" y="1627631"/>
+            <a:ext cx="4480559" cy="457200"/>
           </a:xfrm>
           <a:prstGeom prst="rect">
             <a:avLst/>
@@ -6048,37 +5972,58 @@
           <a:noFill/>
         </p:spPr>
         <p:txBody>
-          <a:bodyPr wrap="square">
+          <a:bodyPr wrap="square" anchor="t" lIns="73152" rIns="73152" tIns="27432" bIns="27432">
             <a:spAutoFit/>
           </a:bodyPr>
           <a:lstStyle/>
           <a:p>
-            <a:pPr>
-              <a:spcAft>
-                <a:spcPts val="800"/>
-              </a:spcAft>
-              <a:defRPr sz="2400" b="1">
+            <a:pPr algn="l">
+              <a:spcBef>
+                <a:spcPts val="0"/>
+              </a:spcBef>
+              <a:spcAft>
+                <a:spcPts val="100"/>
+              </a:spcAft>
+            </a:pPr>
+            <a:r>
+              <a:rPr sz="1300" b="1">
+                <a:solidFill>
+                  <a:srgbClr val="F0F2F8"/>
+                </a:solidFill>
+              </a:rPr>
+              <a:t>ANDROID DEVICE</a:t>
+            </a:r>
+          </a:p>
+          <a:p>
+            <a:pPr algn="l">
+              <a:spcBef>
+                <a:spcPts val="0"/>
+              </a:spcBef>
+              <a:spcAft>
+                <a:spcPts val="100"/>
+              </a:spcAft>
+            </a:pPr>
+            <a:r>
+              <a:rPr sz="950" b="0">
                 <a:solidFill>
                   <a:srgbClr val="FFB02E"/>
                 </a:solidFill>
-              </a:defRPr>
-            </a:pPr>
-            <a:r>
-              <a:t>Backend (Node + Mongo)</a:t>
-            </a:r>
-          </a:p>
-        </p:txBody>
-      </p:sp>
-      <p:sp>
-        <p:nvSpPr>
-          <p:cNvPr id="9" name="TextBox 8"/>
+              </a:rPr>
+              <a:t>Kotlin · acts — no target-app cooperation</a:t>
+            </a:r>
+          </a:p>
+        </p:txBody>
+      </p:sp>
+      <p:sp>
+        <p:nvSpPr>
+          <p:cNvPr id="7" name="TextBox 6"/>
           <p:cNvSpPr txBox="1"/>
           <p:nvPr/>
         </p:nvSpPr>
         <p:spPr>
           <a:xfrm>
-            <a:off x="6400800" y="2331720"/>
-            <a:ext cx="5120640" cy="3383279"/>
+            <a:off x="7040880" y="1627631"/>
+            <a:ext cx="4480559" cy="457200"/>
           </a:xfrm>
           <a:prstGeom prst="rect">
             <a:avLst/>
@@ -6086,43 +6031,1975 @@
           <a:noFill/>
         </p:spPr>
         <p:txBody>
-          <a:bodyPr wrap="square">
+          <a:bodyPr wrap="square" anchor="t" lIns="73152" rIns="73152" tIns="27432" bIns="27432">
             <a:spAutoFit/>
           </a:bodyPr>
           <a:lstStyle/>
           <a:p>
-            <a:pPr>
-              <a:spcAft>
-                <a:spcPts val="800"/>
-              </a:spcAft>
-              <a:defRPr sz="2000" b="0">
+            <a:pPr algn="l">
+              <a:spcBef>
+                <a:spcPts val="0"/>
+              </a:spcBef>
+              <a:spcAft>
+                <a:spcPts val="100"/>
+              </a:spcAft>
+            </a:pPr>
+            <a:r>
+              <a:rPr sz="1300" b="1">
                 <a:solidFill>
                   <a:srgbClr val="F0F2F8"/>
                 </a:solidFill>
-              </a:defRPr>
-            </a:pPr>
-            <a:r>
-              <a:t>WebSocket: audio to Deepgram Nova 3 STT</a:t>
-            </a:r>
-            <a:br/>
-            <a:r>
-              <a:t>Groq JSON mode: intent + slots, generalise, paraphrase match, pick-element fallback</a:t>
-            </a:r>
-            <a:br/>
-            <a:r>
-              <a:t>Deepgram Aura TTS over the same socket</a:t>
-            </a:r>
-            <a:br/>
-            <a:r>
-              <a:t>Mongo: Flow + RunLog</a:t>
-            </a:r>
-            <a:br/>
-            <a:r>
-              <a:t>REST + /dashboard metrics from real RunLogs</a:t>
-            </a:r>
-            <a:br/>
-            <a:r>
-              <a:t>docker compose up</a:t>
+              </a:rPr>
+              <a:t>BACKEND</a:t>
+            </a:r>
+          </a:p>
+          <a:p>
+            <a:pPr algn="l">
+              <a:spcBef>
+                <a:spcPts val="0"/>
+              </a:spcBef>
+              <a:spcAft>
+                <a:spcPts val="100"/>
+              </a:spcAft>
+            </a:pPr>
+            <a:r>
+              <a:rPr sz="950" b="0">
+                <a:solidFill>
+                  <a:srgbClr val="FFB02E"/>
+                </a:solidFill>
+              </a:rPr>
+              <a:t>Node + MongoDB · Docker — understands</a:t>
+            </a:r>
+          </a:p>
+        </p:txBody>
+      </p:sp>
+      <p:sp>
+        <p:nvSpPr>
+          <p:cNvPr id="8" name="Rounded Rectangle 7"/>
+          <p:cNvSpPr/>
+          <p:nvPr/>
+        </p:nvSpPr>
+        <p:spPr>
+          <a:xfrm>
+            <a:off x="704088" y="2231136"/>
+            <a:ext cx="4443983" cy="502920"/>
+          </a:xfrm>
+          <a:prstGeom prst="roundRect">
+            <a:avLst>
+              <a:gd name="adj" fmla="val 9000"/>
+            </a:avLst>
+          </a:prstGeom>
+          <a:solidFill>
+            <a:srgbClr val="2B3345"/>
+          </a:solidFill>
+          <a:ln>
+            <a:noFill/>
+          </a:ln>
+          <a:effectLst/>
+        </p:spPr>
+        <p:style>
+          <a:lnRef idx="1">
+            <a:schemeClr val="accent1"/>
+          </a:lnRef>
+          <a:fillRef idx="3">
+            <a:schemeClr val="accent1"/>
+          </a:fillRef>
+          <a:effectRef idx="2">
+            <a:schemeClr val="accent1"/>
+          </a:effectRef>
+          <a:fontRef idx="minor">
+            <a:schemeClr val="lt1"/>
+          </a:fontRef>
+        </p:style>
+        <p:txBody>
+          <a:bodyPr rtlCol="0" anchor="ctr" wrap="square" lIns="73152" rIns="73152" tIns="27432" bIns="27432"/>
+          <a:lstStyle/>
+          <a:p>
+            <a:pPr algn="l">
+              <a:spcBef>
+                <a:spcPts val="0"/>
+              </a:spcBef>
+              <a:spcAft>
+                <a:spcPts val="100"/>
+              </a:spcAft>
+            </a:pPr>
+            <a:r>
+              <a:rPr sz="1050" b="1">
+                <a:solidFill>
+                  <a:srgbClr val="F0F2F8"/>
+                </a:solidFill>
+              </a:rPr>
+              <a:t>Voice Overlay + Foreground Service</a:t>
+            </a:r>
+          </a:p>
+          <a:p>
+            <a:pPr algn="l">
+              <a:spcBef>
+                <a:spcPts val="0"/>
+              </a:spcBef>
+              <a:spcAft>
+                <a:spcPts val="100"/>
+              </a:spcAft>
+            </a:pPr>
+            <a:r>
+              <a:rPr sz="900" b="0">
+                <a:solidFill>
+                  <a:srgbClr val="969EB0"/>
+                </a:solidFill>
+              </a:rPr>
+              <a:t>push-to-talk mic  ·  plays spoken replies</a:t>
+            </a:r>
+          </a:p>
+        </p:txBody>
+      </p:sp>
+      <p:sp>
+        <p:nvSpPr>
+          <p:cNvPr id="9" name="Rounded Rectangle 8"/>
+          <p:cNvSpPr/>
+          <p:nvPr/>
+        </p:nvSpPr>
+        <p:spPr>
+          <a:xfrm>
+            <a:off x="704088" y="2889504"/>
+            <a:ext cx="4443983" cy="932688"/>
+          </a:xfrm>
+          <a:prstGeom prst="roundRect">
+            <a:avLst>
+              <a:gd name="adj" fmla="val 9000"/>
+            </a:avLst>
+          </a:prstGeom>
+          <a:solidFill>
+            <a:srgbClr val="2B3345"/>
+          </a:solidFill>
+          <a:ln>
+            <a:noFill/>
+          </a:ln>
+          <a:effectLst/>
+        </p:spPr>
+        <p:style>
+          <a:lnRef idx="1">
+            <a:schemeClr val="accent1"/>
+          </a:lnRef>
+          <a:fillRef idx="3">
+            <a:schemeClr val="accent1"/>
+          </a:fillRef>
+          <a:effectRef idx="2">
+            <a:schemeClr val="accent1"/>
+          </a:effectRef>
+          <a:fontRef idx="minor">
+            <a:schemeClr val="lt1"/>
+          </a:fontRef>
+        </p:style>
+        <p:txBody>
+          <a:bodyPr rtlCol="0" anchor="t" wrap="square" lIns="73152" rIns="73152" tIns="27432" bIns="27432"/>
+          <a:lstStyle/>
+          <a:p>
+            <a:pPr algn="l">
+              <a:spcBef>
+                <a:spcPts val="0"/>
+              </a:spcBef>
+              <a:spcAft>
+                <a:spcPts val="100"/>
+              </a:spcAft>
+            </a:pPr>
+            <a:r>
+              <a:rPr sz="1050" b="1">
+                <a:solidFill>
+                  <a:srgbClr val="F0F2F8"/>
+                </a:solidFill>
+              </a:rPr>
+              <a:t>AccessibilityService</a:t>
+            </a:r>
+          </a:p>
+          <a:p>
+            <a:pPr algn="l">
+              <a:spcBef>
+                <a:spcPts val="0"/>
+              </a:spcBef>
+              <a:spcAft>
+                <a:spcPts val="100"/>
+              </a:spcAft>
+            </a:pPr>
+            <a:r>
+              <a:rPr sz="869" b="0">
+                <a:solidFill>
+                  <a:srgbClr val="969EB0"/>
+                </a:solidFill>
+              </a:rPr>
+              <a:t>reads UI tree (id · text · desc · bounds)  ·  taps / types / scrolls / back</a:t>
+            </a:r>
+          </a:p>
+        </p:txBody>
+      </p:sp>
+      <p:sp>
+        <p:nvSpPr>
+          <p:cNvPr id="10" name="Rounded Rectangle 9"/>
+          <p:cNvSpPr/>
+          <p:nvPr/>
+        </p:nvSpPr>
+        <p:spPr>
+          <a:xfrm>
+            <a:off x="795528" y="3273552"/>
+            <a:ext cx="2084831" cy="457200"/>
+          </a:xfrm>
+          <a:prstGeom prst="roundRect">
+            <a:avLst>
+              <a:gd name="adj" fmla="val 9000"/>
+            </a:avLst>
+          </a:prstGeom>
+          <a:solidFill>
+            <a:srgbClr val="222836"/>
+          </a:solidFill>
+          <a:ln>
+            <a:noFill/>
+          </a:ln>
+          <a:effectLst/>
+        </p:spPr>
+        <p:style>
+          <a:lnRef idx="1">
+            <a:schemeClr val="accent1"/>
+          </a:lnRef>
+          <a:fillRef idx="3">
+            <a:schemeClr val="accent1"/>
+          </a:fillRef>
+          <a:effectRef idx="2">
+            <a:schemeClr val="accent1"/>
+          </a:effectRef>
+          <a:fontRef idx="minor">
+            <a:schemeClr val="lt1"/>
+          </a:fontRef>
+        </p:style>
+        <p:txBody>
+          <a:bodyPr rtlCol="0" anchor="ctr" wrap="square" lIns="73152" rIns="73152" tIns="27432" bIns="27432"/>
+          <a:lstStyle/>
+          <a:p>
+            <a:pPr algn="l">
+              <a:spcBef>
+                <a:spcPts val="0"/>
+              </a:spcBef>
+              <a:spcAft>
+                <a:spcPts val="0"/>
+              </a:spcAft>
+            </a:pPr>
+            <a:r>
+              <a:rPr sz="930" b="1">
+                <a:solidFill>
+                  <a:srgbClr val="FFB02E"/>
+                </a:solidFill>
+              </a:rPr>
+              <a:t>Flow Recorder</a:t>
+            </a:r>
+          </a:p>
+          <a:p>
+            <a:pPr algn="l">
+              <a:spcBef>
+                <a:spcPts val="0"/>
+              </a:spcBef>
+              <a:spcAft>
+                <a:spcPts val="0"/>
+              </a:spcAft>
+            </a:pPr>
+            <a:r>
+              <a:rPr sz="800" b="0">
+                <a:solidFill>
+                  <a:srgbClr val="969EB0"/>
+                </a:solidFill>
+              </a:rPr>
+              <a:t>teach: events → selectors</a:t>
+            </a:r>
+          </a:p>
+        </p:txBody>
+      </p:sp>
+      <p:sp>
+        <p:nvSpPr>
+          <p:cNvPr id="11" name="Rounded Rectangle 10"/>
+          <p:cNvSpPr/>
+          <p:nvPr/>
+        </p:nvSpPr>
+        <p:spPr>
+          <a:xfrm>
+            <a:off x="2971800" y="3273552"/>
+            <a:ext cx="2084831" cy="457200"/>
+          </a:xfrm>
+          <a:prstGeom prst="roundRect">
+            <a:avLst>
+              <a:gd name="adj" fmla="val 9000"/>
+            </a:avLst>
+          </a:prstGeom>
+          <a:solidFill>
+            <a:srgbClr val="222836"/>
+          </a:solidFill>
+          <a:ln>
+            <a:noFill/>
+          </a:ln>
+          <a:effectLst/>
+        </p:spPr>
+        <p:style>
+          <a:lnRef idx="1">
+            <a:schemeClr val="accent1"/>
+          </a:lnRef>
+          <a:fillRef idx="3">
+            <a:schemeClr val="accent1"/>
+          </a:fillRef>
+          <a:effectRef idx="2">
+            <a:schemeClr val="accent1"/>
+          </a:effectRef>
+          <a:fontRef idx="minor">
+            <a:schemeClr val="lt1"/>
+          </a:fontRef>
+        </p:style>
+        <p:txBody>
+          <a:bodyPr rtlCol="0" anchor="ctr" wrap="square" lIns="73152" rIns="73152" tIns="27432" bIns="27432"/>
+          <a:lstStyle/>
+          <a:p>
+            <a:pPr algn="l">
+              <a:spcBef>
+                <a:spcPts val="0"/>
+              </a:spcBef>
+              <a:spcAft>
+                <a:spcPts val="0"/>
+              </a:spcAft>
+            </a:pPr>
+            <a:r>
+              <a:rPr sz="930" b="1">
+                <a:solidFill>
+                  <a:srgbClr val="4EA1FF"/>
+                </a:solidFill>
+              </a:rPr>
+              <a:t>Replayer + ScreenGuard</a:t>
+            </a:r>
+          </a:p>
+          <a:p>
+            <a:pPr algn="l">
+              <a:spcBef>
+                <a:spcPts val="0"/>
+              </a:spcBef>
+              <a:spcAft>
+                <a:spcPts val="0"/>
+              </a:spcAft>
+            </a:pPr>
+            <a:r>
+              <a:rPr sz="800" b="0">
+                <a:solidFill>
+                  <a:srgbClr val="969EB0"/>
+                </a:solidFill>
+              </a:rPr>
+              <a:t>replay: match · guard pay/OTP</a:t>
+            </a:r>
+          </a:p>
+        </p:txBody>
+      </p:sp>
+      <p:sp>
+        <p:nvSpPr>
+          <p:cNvPr id="12" name="Rounded Rectangle 11"/>
+          <p:cNvSpPr/>
+          <p:nvPr/>
+        </p:nvSpPr>
+        <p:spPr>
+          <a:xfrm>
+            <a:off x="704088" y="4078224"/>
+            <a:ext cx="4443983" cy="457200"/>
+          </a:xfrm>
+          <a:prstGeom prst="roundRect">
+            <a:avLst>
+              <a:gd name="adj" fmla="val 9000"/>
+            </a:avLst>
+          </a:prstGeom>
+          <a:solidFill>
+            <a:srgbClr val="222836"/>
+          </a:solidFill>
+          <a:ln w="9525">
+            <a:solidFill>
+              <a:srgbClr val="3C4763"/>
+            </a:solidFill>
+          </a:ln>
+          <a:effectLst/>
+        </p:spPr>
+        <p:style>
+          <a:lnRef idx="1">
+            <a:schemeClr val="accent1"/>
+          </a:lnRef>
+          <a:fillRef idx="3">
+            <a:schemeClr val="accent1"/>
+          </a:fillRef>
+          <a:effectRef idx="2">
+            <a:schemeClr val="accent1"/>
+          </a:effectRef>
+          <a:fontRef idx="minor">
+            <a:schemeClr val="lt1"/>
+          </a:fontRef>
+        </p:style>
+        <p:txBody>
+          <a:bodyPr rtlCol="0" anchor="ctr" wrap="square" lIns="73152" rIns="73152" tIns="27432" bIns="27432"/>
+          <a:lstStyle/>
+          <a:p>
+            <a:pPr algn="l">
+              <a:spcBef>
+                <a:spcPts val="0"/>
+              </a:spcBef>
+              <a:spcAft>
+                <a:spcPts val="0"/>
+              </a:spcAft>
+            </a:pPr>
+            <a:r>
+              <a:rPr sz="980" b="1">
+                <a:solidFill>
+                  <a:srgbClr val="F0F2F8"/>
+                </a:solidFill>
+              </a:rPr>
+              <a:t>Target app</a:t>
+            </a:r>
+          </a:p>
+          <a:p>
+            <a:pPr algn="l">
+              <a:spcBef>
+                <a:spcPts val="0"/>
+              </a:spcBef>
+              <a:spcAft>
+                <a:spcPts val="0"/>
+              </a:spcAft>
+            </a:pPr>
+            <a:r>
+              <a:rPr sz="850" b="0">
+                <a:solidFill>
+                  <a:srgbClr val="969EB0"/>
+                </a:solidFill>
+              </a:rPr>
+              <a:t>Zomato · Settings · Calculator — unmodified</a:t>
+            </a:r>
+          </a:p>
+        </p:txBody>
+      </p:sp>
+      <p:sp>
+        <p:nvSpPr>
+          <p:cNvPr id="13" name="Rounded Rectangle 12"/>
+          <p:cNvSpPr/>
+          <p:nvPr/>
+        </p:nvSpPr>
+        <p:spPr>
+          <a:xfrm>
+            <a:off x="7040880" y="2231136"/>
+            <a:ext cx="4443983" cy="502920"/>
+          </a:xfrm>
+          <a:prstGeom prst="roundRect">
+            <a:avLst>
+              <a:gd name="adj" fmla="val 9000"/>
+            </a:avLst>
+          </a:prstGeom>
+          <a:solidFill>
+            <a:srgbClr val="2B3345"/>
+          </a:solidFill>
+          <a:ln>
+            <a:noFill/>
+          </a:ln>
+          <a:effectLst/>
+        </p:spPr>
+        <p:style>
+          <a:lnRef idx="1">
+            <a:schemeClr val="accent1"/>
+          </a:lnRef>
+          <a:fillRef idx="3">
+            <a:schemeClr val="accent1"/>
+          </a:fillRef>
+          <a:effectRef idx="2">
+            <a:schemeClr val="accent1"/>
+          </a:effectRef>
+          <a:fontRef idx="minor">
+            <a:schemeClr val="lt1"/>
+          </a:fontRef>
+        </p:style>
+        <p:txBody>
+          <a:bodyPr rtlCol="0" anchor="ctr" wrap="square" lIns="73152" rIns="73152" tIns="27432" bIns="27432"/>
+          <a:lstStyle/>
+          <a:p>
+            <a:pPr algn="l">
+              <a:spcBef>
+                <a:spcPts val="0"/>
+              </a:spcBef>
+              <a:spcAft>
+                <a:spcPts val="100"/>
+              </a:spcAft>
+            </a:pPr>
+            <a:r>
+              <a:rPr sz="1050" b="1">
+                <a:solidFill>
+                  <a:srgbClr val="F0F2F8"/>
+                </a:solidFill>
+              </a:rPr>
+              <a:t>WebSocket Gateway + Session orchestrator</a:t>
+            </a:r>
+          </a:p>
+          <a:p>
+            <a:pPr algn="l">
+              <a:spcBef>
+                <a:spcPts val="0"/>
+              </a:spcBef>
+              <a:spcAft>
+                <a:spcPts val="100"/>
+              </a:spcAft>
+            </a:pPr>
+            <a:r>
+              <a:rPr sz="900" b="0">
+                <a:solidFill>
+                  <a:srgbClr val="969EB0"/>
+                </a:solidFill>
+              </a:rPr>
+              <a:t>routes audio, drives teach / replay loop</a:t>
+            </a:r>
+          </a:p>
+        </p:txBody>
+      </p:sp>
+      <p:sp>
+        <p:nvSpPr>
+          <p:cNvPr id="14" name="Rounded Rectangle 13"/>
+          <p:cNvSpPr/>
+          <p:nvPr/>
+        </p:nvSpPr>
+        <p:spPr>
+          <a:xfrm>
+            <a:off x="7040880" y="2816352"/>
+            <a:ext cx="4443983" cy="457200"/>
+          </a:xfrm>
+          <a:prstGeom prst="roundRect">
+            <a:avLst>
+              <a:gd name="adj" fmla="val 9000"/>
+            </a:avLst>
+          </a:prstGeom>
+          <a:solidFill>
+            <a:srgbClr val="2B3345"/>
+          </a:solidFill>
+          <a:ln>
+            <a:noFill/>
+          </a:ln>
+          <a:effectLst/>
+        </p:spPr>
+        <p:style>
+          <a:lnRef idx="1">
+            <a:schemeClr val="accent1"/>
+          </a:lnRef>
+          <a:fillRef idx="3">
+            <a:schemeClr val="accent1"/>
+          </a:fillRef>
+          <a:effectRef idx="2">
+            <a:schemeClr val="accent1"/>
+          </a:effectRef>
+          <a:fontRef idx="minor">
+            <a:schemeClr val="lt1"/>
+          </a:fontRef>
+        </p:style>
+        <p:txBody>
+          <a:bodyPr rtlCol="0" anchor="ctr" wrap="square" lIns="73152" rIns="73152" tIns="27432" bIns="27432"/>
+          <a:lstStyle/>
+          <a:p>
+            <a:pPr algn="l">
+              <a:spcBef>
+                <a:spcPts val="0"/>
+              </a:spcBef>
+              <a:spcAft>
+                <a:spcPts val="0"/>
+              </a:spcAft>
+            </a:pPr>
+            <a:r>
+              <a:rPr sz="1030" b="1">
+                <a:solidFill>
+                  <a:srgbClr val="F0F2F8"/>
+                </a:solidFill>
+              </a:rPr>
+              <a:t>Deepgram</a:t>
+            </a:r>
+          </a:p>
+          <a:p>
+            <a:pPr algn="l">
+              <a:spcBef>
+                <a:spcPts val="0"/>
+              </a:spcBef>
+              <a:spcAft>
+                <a:spcPts val="0"/>
+              </a:spcAft>
+            </a:pPr>
+            <a:r>
+              <a:rPr sz="869" b="0">
+                <a:solidFill>
+                  <a:srgbClr val="969EB0"/>
+                </a:solidFill>
+              </a:rPr>
+              <a:t>Nova-3 STT (audio → text)  ·  Aura TTS (text → audio)</a:t>
+            </a:r>
+          </a:p>
+        </p:txBody>
+      </p:sp>
+      <p:sp>
+        <p:nvSpPr>
+          <p:cNvPr id="15" name="Rounded Rectangle 14"/>
+          <p:cNvSpPr/>
+          <p:nvPr/>
+        </p:nvSpPr>
+        <p:spPr>
+          <a:xfrm>
+            <a:off x="7040880" y="3346704"/>
+            <a:ext cx="4443983" cy="731520"/>
+          </a:xfrm>
+          <a:prstGeom prst="roundRect">
+            <a:avLst>
+              <a:gd name="adj" fmla="val 9000"/>
+            </a:avLst>
+          </a:prstGeom>
+          <a:solidFill>
+            <a:srgbClr val="2B3345"/>
+          </a:solidFill>
+          <a:ln>
+            <a:noFill/>
+          </a:ln>
+          <a:effectLst/>
+        </p:spPr>
+        <p:style>
+          <a:lnRef idx="1">
+            <a:schemeClr val="accent1"/>
+          </a:lnRef>
+          <a:fillRef idx="3">
+            <a:schemeClr val="accent1"/>
+          </a:fillRef>
+          <a:effectRef idx="2">
+            <a:schemeClr val="accent1"/>
+          </a:effectRef>
+          <a:fontRef idx="minor">
+            <a:schemeClr val="lt1"/>
+          </a:fontRef>
+        </p:style>
+        <p:txBody>
+          <a:bodyPr rtlCol="0" anchor="t" wrap="square" lIns="73152" rIns="73152" tIns="27432" bIns="27432"/>
+          <a:lstStyle/>
+          <a:p>
+            <a:pPr algn="l">
+              <a:spcBef>
+                <a:spcPts val="0"/>
+              </a:spcBef>
+              <a:spcAft>
+                <a:spcPts val="100"/>
+              </a:spcAft>
+            </a:pPr>
+            <a:r>
+              <a:rPr sz="1030" b="1">
+                <a:solidFill>
+                  <a:srgbClr val="F0F2F8"/>
+                </a:solidFill>
+              </a:rPr>
+              <a:t>Groq LLM  —  JSON mode</a:t>
+            </a:r>
+          </a:p>
+          <a:p>
+            <a:pPr algn="l">
+              <a:spcBef>
+                <a:spcPts val="0"/>
+              </a:spcBef>
+              <a:spcAft>
+                <a:spcPts val="100"/>
+              </a:spcAft>
+            </a:pPr>
+            <a:r>
+              <a:rPr sz="860" b="0">
+                <a:solidFill>
+                  <a:srgbClr val="969EB0"/>
+                </a:solidFill>
+              </a:rPr>
+              <a:t>intent + slots   ·   generalise demo → flow</a:t>
+            </a:r>
+          </a:p>
+          <a:p>
+            <a:pPr algn="l">
+              <a:spcBef>
+                <a:spcPts val="0"/>
+              </a:spcBef>
+              <a:spcAft>
+                <a:spcPts val="100"/>
+              </a:spcAft>
+            </a:pPr>
+            <a:r>
+              <a:rPr sz="860" b="0">
+                <a:solidFill>
+                  <a:srgbClr val="969EB0"/>
+                </a:solidFill>
+              </a:rPr>
+              <a:t>paraphrase match   ·   pick-element fallback</a:t>
+            </a:r>
+          </a:p>
+        </p:txBody>
+      </p:sp>
+      <p:sp>
+        <p:nvSpPr>
+          <p:cNvPr id="16" name="Rounded Rectangle 15"/>
+          <p:cNvSpPr/>
+          <p:nvPr/>
+        </p:nvSpPr>
+        <p:spPr>
+          <a:xfrm>
+            <a:off x="7040880" y="4151376"/>
+            <a:ext cx="4443983" cy="402336"/>
+          </a:xfrm>
+          <a:prstGeom prst="roundRect">
+            <a:avLst>
+              <a:gd name="adj" fmla="val 9000"/>
+            </a:avLst>
+          </a:prstGeom>
+          <a:solidFill>
+            <a:srgbClr val="2B3345"/>
+          </a:solidFill>
+          <a:ln>
+            <a:noFill/>
+          </a:ln>
+          <a:effectLst/>
+        </p:spPr>
+        <p:style>
+          <a:lnRef idx="1">
+            <a:schemeClr val="accent1"/>
+          </a:lnRef>
+          <a:fillRef idx="3">
+            <a:schemeClr val="accent1"/>
+          </a:fillRef>
+          <a:effectRef idx="2">
+            <a:schemeClr val="accent1"/>
+          </a:effectRef>
+          <a:fontRef idx="minor">
+            <a:schemeClr val="lt1"/>
+          </a:fontRef>
+        </p:style>
+        <p:txBody>
+          <a:bodyPr rtlCol="0" anchor="ctr" wrap="square" lIns="73152" rIns="73152" tIns="27432" bIns="27432"/>
+          <a:lstStyle/>
+          <a:p>
+            <a:pPr algn="l">
+              <a:spcBef>
+                <a:spcPts val="0"/>
+              </a:spcBef>
+              <a:spcAft>
+                <a:spcPts val="0"/>
+              </a:spcAft>
+            </a:pPr>
+            <a:r>
+              <a:rPr sz="919" b="1">
+                <a:solidFill>
+                  <a:srgbClr val="F0F2F8"/>
+                </a:solidFill>
+              </a:rPr>
+              <a:t>MongoDB: Flows + RunLogs   ·   REST /dashboard metrics</a:t>
+            </a:r>
+          </a:p>
+        </p:txBody>
+      </p:sp>
+      <p:cxnSp>
+        <p:nvCxnSpPr>
+          <p:cNvPr id="17" name="Connector 16"/>
+          <p:cNvCxnSpPr/>
+          <p:nvPr/>
+        </p:nvCxnSpPr>
+        <p:spPr>
+          <a:xfrm>
+            <a:off x="2926079" y="2734056"/>
+            <a:ext cx="0" cy="155448"/>
+          </a:xfrm>
+          <a:prstGeom prst="bentConnector3">
+            <a:avLst/>
+          </a:prstGeom>
+          <a:ln w="17780">
+            <a:solidFill>
+              <a:srgbClr val="3C4763"/>
+            </a:solidFill>
+            <a:tailEnd type="triangle" w="med" len="med"/>
+          </a:ln>
+        </p:spPr>
+        <p:style>
+          <a:lnRef idx="2">
+            <a:schemeClr val="accent1"/>
+          </a:lnRef>
+          <a:fillRef idx="0">
+            <a:schemeClr val="accent1"/>
+          </a:fillRef>
+          <a:effectRef idx="1">
+            <a:schemeClr val="accent1"/>
+          </a:effectRef>
+          <a:fontRef idx="minor">
+            <a:schemeClr val="tx1"/>
+          </a:fontRef>
+        </p:style>
+      </p:cxnSp>
+      <p:cxnSp>
+        <p:nvCxnSpPr>
+          <p:cNvPr id="18" name="Connector 17"/>
+          <p:cNvCxnSpPr/>
+          <p:nvPr/>
+        </p:nvCxnSpPr>
+        <p:spPr>
+          <a:xfrm>
+            <a:off x="2926079" y="3822191"/>
+            <a:ext cx="0" cy="256033"/>
+          </a:xfrm>
+          <a:prstGeom prst="bentConnector3">
+            <a:avLst/>
+          </a:prstGeom>
+          <a:ln w="20320">
+            <a:solidFill>
+              <a:srgbClr val="3C4763"/>
+            </a:solidFill>
+            <a:headEnd type="triangle" w="med" len="med"/>
+            <a:tailEnd type="triangle" w="med" len="med"/>
+          </a:ln>
+        </p:spPr>
+        <p:style>
+          <a:lnRef idx="2">
+            <a:schemeClr val="accent1"/>
+          </a:lnRef>
+          <a:fillRef idx="0">
+            <a:schemeClr val="accent1"/>
+          </a:fillRef>
+          <a:effectRef idx="1">
+            <a:schemeClr val="accent1"/>
+          </a:effectRef>
+          <a:fontRef idx="minor">
+            <a:schemeClr val="tx1"/>
+          </a:fontRef>
+        </p:style>
+      </p:cxnSp>
+      <p:cxnSp>
+        <p:nvCxnSpPr>
+          <p:cNvPr id="19" name="Connector 18"/>
+          <p:cNvCxnSpPr/>
+          <p:nvPr/>
+        </p:nvCxnSpPr>
+        <p:spPr>
+          <a:xfrm>
+            <a:off x="9262872" y="2734056"/>
+            <a:ext cx="0" cy="82296"/>
+          </a:xfrm>
+          <a:prstGeom prst="bentConnector3">
+            <a:avLst/>
+          </a:prstGeom>
+          <a:ln w="17780">
+            <a:solidFill>
+              <a:srgbClr val="3C4763"/>
+            </a:solidFill>
+            <a:tailEnd type="triangle" w="med" len="med"/>
+          </a:ln>
+        </p:spPr>
+        <p:style>
+          <a:lnRef idx="2">
+            <a:schemeClr val="accent1"/>
+          </a:lnRef>
+          <a:fillRef idx="0">
+            <a:schemeClr val="accent1"/>
+          </a:fillRef>
+          <a:effectRef idx="1">
+            <a:schemeClr val="accent1"/>
+          </a:effectRef>
+          <a:fontRef idx="minor">
+            <a:schemeClr val="tx1"/>
+          </a:fontRef>
+        </p:style>
+      </p:cxnSp>
+      <p:cxnSp>
+        <p:nvCxnSpPr>
+          <p:cNvPr id="20" name="Connector 19"/>
+          <p:cNvCxnSpPr/>
+          <p:nvPr/>
+        </p:nvCxnSpPr>
+        <p:spPr>
+          <a:xfrm>
+            <a:off x="9262872" y="3273552"/>
+            <a:ext cx="0" cy="73152"/>
+          </a:xfrm>
+          <a:prstGeom prst="bentConnector3">
+            <a:avLst/>
+          </a:prstGeom>
+          <a:ln w="17780">
+            <a:solidFill>
+              <a:srgbClr val="3C4763"/>
+            </a:solidFill>
+            <a:tailEnd type="triangle" w="med" len="med"/>
+          </a:ln>
+        </p:spPr>
+        <p:style>
+          <a:lnRef idx="2">
+            <a:schemeClr val="accent1"/>
+          </a:lnRef>
+          <a:fillRef idx="0">
+            <a:schemeClr val="accent1"/>
+          </a:fillRef>
+          <a:effectRef idx="1">
+            <a:schemeClr val="accent1"/>
+          </a:effectRef>
+          <a:fontRef idx="minor">
+            <a:schemeClr val="tx1"/>
+          </a:fontRef>
+        </p:style>
+      </p:cxnSp>
+      <p:cxnSp>
+        <p:nvCxnSpPr>
+          <p:cNvPr id="21" name="Connector 20"/>
+          <p:cNvCxnSpPr/>
+          <p:nvPr/>
+        </p:nvCxnSpPr>
+        <p:spPr>
+          <a:xfrm>
+            <a:off x="9262872" y="4078224"/>
+            <a:ext cx="0" cy="73152"/>
+          </a:xfrm>
+          <a:prstGeom prst="bentConnector3">
+            <a:avLst/>
+          </a:prstGeom>
+          <a:ln w="17780">
+            <a:solidFill>
+              <a:srgbClr val="3C4763"/>
+            </a:solidFill>
+            <a:tailEnd type="triangle" w="med" len="med"/>
+          </a:ln>
+        </p:spPr>
+        <p:style>
+          <a:lnRef idx="2">
+            <a:schemeClr val="accent1"/>
+          </a:lnRef>
+          <a:fillRef idx="0">
+            <a:schemeClr val="accent1"/>
+          </a:fillRef>
+          <a:effectRef idx="1">
+            <a:schemeClr val="accent1"/>
+          </a:effectRef>
+          <a:fontRef idx="minor">
+            <a:schemeClr val="tx1"/>
+          </a:fontRef>
+        </p:style>
+      </p:cxnSp>
+      <p:sp>
+        <p:nvSpPr>
+          <p:cNvPr id="22" name="Rounded Rectangle 21"/>
+          <p:cNvSpPr/>
+          <p:nvPr/>
+        </p:nvSpPr>
+        <p:spPr>
+          <a:xfrm>
+            <a:off x="5504688" y="2231136"/>
+            <a:ext cx="1243584" cy="502920"/>
+          </a:xfrm>
+          <a:prstGeom prst="roundRect">
+            <a:avLst>
+              <a:gd name="adj" fmla="val 16000"/>
+            </a:avLst>
+          </a:prstGeom>
+          <a:solidFill>
+            <a:srgbClr val="242B3D"/>
+          </a:solidFill>
+          <a:ln w="15875">
+            <a:solidFill>
+              <a:srgbClr val="FFB02E"/>
+            </a:solidFill>
+          </a:ln>
+          <a:effectLst/>
+        </p:spPr>
+        <p:style>
+          <a:lnRef idx="1">
+            <a:schemeClr val="accent1"/>
+          </a:lnRef>
+          <a:fillRef idx="3">
+            <a:schemeClr val="accent1"/>
+          </a:fillRef>
+          <a:effectRef idx="2">
+            <a:schemeClr val="accent1"/>
+          </a:effectRef>
+          <a:fontRef idx="minor">
+            <a:schemeClr val="lt1"/>
+          </a:fontRef>
+        </p:style>
+        <p:txBody>
+          <a:bodyPr rtlCol="0" anchor="ctr" wrap="square" lIns="73152" rIns="73152" tIns="27432" bIns="27432"/>
+          <a:lstStyle/>
+          <a:p>
+            <a:pPr algn="ctr">
+              <a:spcBef>
+                <a:spcPts val="0"/>
+              </a:spcBef>
+              <a:spcAft>
+                <a:spcPts val="200"/>
+              </a:spcAft>
+            </a:pPr>
+            <a:r>
+              <a:rPr sz="1050" b="1">
+                <a:solidFill>
+                  <a:srgbClr val="FFB02E"/>
+                </a:solidFill>
+              </a:rPr>
+              <a:t>WebSocket</a:t>
+            </a:r>
+          </a:p>
+        </p:txBody>
+      </p:sp>
+      <p:sp>
+        <p:nvSpPr>
+          <p:cNvPr id="23" name="TextBox 22"/>
+          <p:cNvSpPr txBox="1"/>
+          <p:nvPr/>
+        </p:nvSpPr>
+        <p:spPr>
+          <a:xfrm>
+            <a:off x="5449824" y="2761488"/>
+            <a:ext cx="1353312" cy="457200"/>
+          </a:xfrm>
+          <a:prstGeom prst="rect">
+            <a:avLst/>
+          </a:prstGeom>
+          <a:noFill/>
+        </p:spPr>
+        <p:txBody>
+          <a:bodyPr wrap="square" anchor="t" lIns="73152" rIns="73152" tIns="27432" bIns="27432">
+            <a:spAutoFit/>
+          </a:bodyPr>
+          <a:lstStyle/>
+          <a:p>
+            <a:pPr algn="ctr">
+              <a:spcBef>
+                <a:spcPts val="0"/>
+              </a:spcBef>
+              <a:spcAft>
+                <a:spcPts val="100"/>
+              </a:spcAft>
+            </a:pPr>
+            <a:r>
+              <a:rPr sz="850" b="1">
+                <a:solidFill>
+                  <a:srgbClr val="F0F2F8"/>
+                </a:solidFill>
+              </a:rPr>
+              <a:t>audio ↑</a:t>
+            </a:r>
+          </a:p>
+          <a:p>
+            <a:pPr algn="ctr">
+              <a:spcBef>
+                <a:spcPts val="0"/>
+              </a:spcBef>
+              <a:spcAft>
+                <a:spcPts val="100"/>
+              </a:spcAft>
+            </a:pPr>
+            <a:r>
+              <a:rPr sz="850" b="1">
+                <a:solidFill>
+                  <a:srgbClr val="F0F2F8"/>
+                </a:solidFill>
+              </a:rPr>
+              <a:t>TTS + flow ↓</a:t>
+            </a:r>
+          </a:p>
+        </p:txBody>
+      </p:sp>
+      <p:cxnSp>
+        <p:nvCxnSpPr>
+          <p:cNvPr id="24" name="Connector 23"/>
+          <p:cNvCxnSpPr/>
+          <p:nvPr/>
+        </p:nvCxnSpPr>
+        <p:spPr>
+          <a:xfrm>
+            <a:off x="5148071" y="2478024"/>
+            <a:ext cx="356617" cy="0"/>
+          </a:xfrm>
+          <a:prstGeom prst="bentConnector3">
+            <a:avLst/>
+          </a:prstGeom>
+          <a:ln w="25400">
+            <a:solidFill>
+              <a:srgbClr val="FFB02E"/>
+            </a:solidFill>
+            <a:headEnd type="triangle" w="med" len="med"/>
+            <a:tailEnd type="triangle" w="med" len="med"/>
+          </a:ln>
+        </p:spPr>
+        <p:style>
+          <a:lnRef idx="2">
+            <a:schemeClr val="accent1"/>
+          </a:lnRef>
+          <a:fillRef idx="0">
+            <a:schemeClr val="accent1"/>
+          </a:fillRef>
+          <a:effectRef idx="1">
+            <a:schemeClr val="accent1"/>
+          </a:effectRef>
+          <a:fontRef idx="minor">
+            <a:schemeClr val="tx1"/>
+          </a:fontRef>
+        </p:style>
+      </p:cxnSp>
+      <p:cxnSp>
+        <p:nvCxnSpPr>
+          <p:cNvPr id="25" name="Connector 24"/>
+          <p:cNvCxnSpPr/>
+          <p:nvPr/>
+        </p:nvCxnSpPr>
+        <p:spPr>
+          <a:xfrm>
+            <a:off x="6748272" y="2478024"/>
+            <a:ext cx="292608" cy="0"/>
+          </a:xfrm>
+          <a:prstGeom prst="bentConnector3">
+            <a:avLst/>
+          </a:prstGeom>
+          <a:ln w="25400">
+            <a:solidFill>
+              <a:srgbClr val="FFB02E"/>
+            </a:solidFill>
+            <a:headEnd type="triangle" w="med" len="med"/>
+            <a:tailEnd type="triangle" w="med" len="med"/>
+          </a:ln>
+        </p:spPr>
+        <p:style>
+          <a:lnRef idx="2">
+            <a:schemeClr val="accent1"/>
+          </a:lnRef>
+          <a:fillRef idx="0">
+            <a:schemeClr val="accent1"/>
+          </a:fillRef>
+          <a:effectRef idx="1">
+            <a:schemeClr val="accent1"/>
+          </a:effectRef>
+          <a:fontRef idx="minor">
+            <a:schemeClr val="tx1"/>
+          </a:fontRef>
+        </p:style>
+      </p:cxnSp>
+      <p:sp>
+        <p:nvSpPr>
+          <p:cNvPr id="26" name="TextBox 25"/>
+          <p:cNvSpPr txBox="1"/>
+          <p:nvPr/>
+        </p:nvSpPr>
+        <p:spPr>
+          <a:xfrm>
+            <a:off x="502920" y="4882896"/>
+            <a:ext cx="5486400" cy="274320"/>
+          </a:xfrm>
+          <a:prstGeom prst="rect">
+            <a:avLst/>
+          </a:prstGeom>
+          <a:noFill/>
+        </p:spPr>
+        <p:txBody>
+          <a:bodyPr wrap="square" anchor="t" lIns="73152" rIns="73152" tIns="27432" bIns="27432">
+            <a:spAutoFit/>
+          </a:bodyPr>
+          <a:lstStyle/>
+          <a:p>
+            <a:pPr algn="l">
+              <a:spcBef>
+                <a:spcPts val="0"/>
+              </a:spcBef>
+              <a:spcAft>
+                <a:spcPts val="100"/>
+              </a:spcAft>
+            </a:pPr>
+            <a:r>
+              <a:rPr sz="1250" b="1">
+                <a:solidFill>
+                  <a:srgbClr val="F0F2F8"/>
+                </a:solidFill>
+              </a:rPr>
+              <a:t>How a command flows</a:t>
+            </a:r>
+          </a:p>
+        </p:txBody>
+      </p:sp>
+      <p:sp>
+        <p:nvSpPr>
+          <p:cNvPr id="27" name="Oval 26"/>
+          <p:cNvSpPr/>
+          <p:nvPr/>
+        </p:nvSpPr>
+        <p:spPr>
+          <a:xfrm>
+            <a:off x="3703320" y="4901183"/>
+            <a:ext cx="146304" cy="146304"/>
+          </a:xfrm>
+          <a:prstGeom prst="ellipse">
+            <a:avLst/>
+          </a:prstGeom>
+          <a:solidFill>
+            <a:srgbClr val="FFB02E"/>
+          </a:solidFill>
+          <a:ln>
+            <a:noFill/>
+          </a:ln>
+          <a:effectLst/>
+        </p:spPr>
+        <p:style>
+          <a:lnRef idx="1">
+            <a:schemeClr val="accent1"/>
+          </a:lnRef>
+          <a:fillRef idx="3">
+            <a:schemeClr val="accent1"/>
+          </a:fillRef>
+          <a:effectRef idx="2">
+            <a:schemeClr val="accent1"/>
+          </a:effectRef>
+          <a:fontRef idx="minor">
+            <a:schemeClr val="lt1"/>
+          </a:fontRef>
+        </p:style>
+        <p:txBody>
+          <a:bodyPr rtlCol="0" anchor="ctr"/>
+          <a:lstStyle/>
+          <a:p>
+            <a:pPr algn="ctr"/>
+          </a:p>
+        </p:txBody>
+      </p:sp>
+      <p:sp>
+        <p:nvSpPr>
+          <p:cNvPr id="28" name="TextBox 27"/>
+          <p:cNvSpPr txBox="1"/>
+          <p:nvPr/>
+        </p:nvSpPr>
+        <p:spPr>
+          <a:xfrm>
+            <a:off x="3895344" y="4864608"/>
+            <a:ext cx="914400" cy="274320"/>
+          </a:xfrm>
+          <a:prstGeom prst="rect">
+            <a:avLst/>
+          </a:prstGeom>
+          <a:noFill/>
+        </p:spPr>
+        <p:txBody>
+          <a:bodyPr wrap="square" anchor="t" lIns="73152" rIns="73152" tIns="27432" bIns="27432">
+            <a:spAutoFit/>
+          </a:bodyPr>
+          <a:lstStyle/>
+          <a:p>
+            <a:pPr algn="l">
+              <a:spcBef>
+                <a:spcPts val="0"/>
+              </a:spcBef>
+              <a:spcAft>
+                <a:spcPts val="100"/>
+              </a:spcAft>
+            </a:pPr>
+            <a:r>
+              <a:rPr sz="950" b="1">
+                <a:solidFill>
+                  <a:srgbClr val="FFB02E"/>
+                </a:solidFill>
+              </a:rPr>
+              <a:t>Teach</a:t>
+            </a:r>
+          </a:p>
+        </p:txBody>
+      </p:sp>
+      <p:sp>
+        <p:nvSpPr>
+          <p:cNvPr id="29" name="Oval 28"/>
+          <p:cNvSpPr/>
+          <p:nvPr/>
+        </p:nvSpPr>
+        <p:spPr>
+          <a:xfrm>
+            <a:off x="4590288" y="4901183"/>
+            <a:ext cx="146304" cy="146304"/>
+          </a:xfrm>
+          <a:prstGeom prst="ellipse">
+            <a:avLst/>
+          </a:prstGeom>
+          <a:solidFill>
+            <a:srgbClr val="4EA1FF"/>
+          </a:solidFill>
+          <a:ln>
+            <a:noFill/>
+          </a:ln>
+          <a:effectLst/>
+        </p:spPr>
+        <p:style>
+          <a:lnRef idx="1">
+            <a:schemeClr val="accent1"/>
+          </a:lnRef>
+          <a:fillRef idx="3">
+            <a:schemeClr val="accent1"/>
+          </a:fillRef>
+          <a:effectRef idx="2">
+            <a:schemeClr val="accent1"/>
+          </a:effectRef>
+          <a:fontRef idx="minor">
+            <a:schemeClr val="lt1"/>
+          </a:fontRef>
+        </p:style>
+        <p:txBody>
+          <a:bodyPr rtlCol="0" anchor="ctr"/>
+          <a:lstStyle/>
+          <a:p>
+            <a:pPr algn="ctr"/>
+          </a:p>
+        </p:txBody>
+      </p:sp>
+      <p:sp>
+        <p:nvSpPr>
+          <p:cNvPr id="30" name="TextBox 29"/>
+          <p:cNvSpPr txBox="1"/>
+          <p:nvPr/>
+        </p:nvSpPr>
+        <p:spPr>
+          <a:xfrm>
+            <a:off x="4782312" y="4864608"/>
+            <a:ext cx="1097280" cy="274320"/>
+          </a:xfrm>
+          <a:prstGeom prst="rect">
+            <a:avLst/>
+          </a:prstGeom>
+          <a:noFill/>
+        </p:spPr>
+        <p:txBody>
+          <a:bodyPr wrap="square" anchor="t" lIns="73152" rIns="73152" tIns="27432" bIns="27432">
+            <a:spAutoFit/>
+          </a:bodyPr>
+          <a:lstStyle/>
+          <a:p>
+            <a:pPr algn="l">
+              <a:spcBef>
+                <a:spcPts val="0"/>
+              </a:spcBef>
+              <a:spcAft>
+                <a:spcPts val="100"/>
+              </a:spcAft>
+            </a:pPr>
+            <a:r>
+              <a:rPr sz="950" b="1">
+                <a:solidFill>
+                  <a:srgbClr val="4EA1FF"/>
+                </a:solidFill>
+              </a:rPr>
+              <a:t>Replay</a:t>
+            </a:r>
+          </a:p>
+        </p:txBody>
+      </p:sp>
+      <p:sp>
+        <p:nvSpPr>
+          <p:cNvPr id="31" name="Rounded Rectangle 30"/>
+          <p:cNvSpPr/>
+          <p:nvPr/>
+        </p:nvSpPr>
+        <p:spPr>
+          <a:xfrm>
+            <a:off x="502920" y="5266944"/>
+            <a:ext cx="932688" cy="512064"/>
+          </a:xfrm>
+          <a:prstGeom prst="roundRect">
+            <a:avLst>
+              <a:gd name="adj" fmla="val 12000"/>
+            </a:avLst>
+          </a:prstGeom>
+          <a:solidFill>
+            <a:srgbClr val="222836"/>
+          </a:solidFill>
+          <a:ln w="13970">
+            <a:solidFill>
+              <a:srgbClr val="FFB02E"/>
+            </a:solidFill>
+          </a:ln>
+          <a:effectLst/>
+        </p:spPr>
+        <p:style>
+          <a:lnRef idx="1">
+            <a:schemeClr val="accent1"/>
+          </a:lnRef>
+          <a:fillRef idx="3">
+            <a:schemeClr val="accent1"/>
+          </a:fillRef>
+          <a:effectRef idx="2">
+            <a:schemeClr val="accent1"/>
+          </a:effectRef>
+          <a:fontRef idx="minor">
+            <a:schemeClr val="lt1"/>
+          </a:fontRef>
+        </p:style>
+        <p:txBody>
+          <a:bodyPr rtlCol="0" anchor="ctr" wrap="square" lIns="73152" rIns="73152" tIns="27432" bIns="27432"/>
+          <a:lstStyle/>
+          <a:p>
+            <a:pPr algn="ctr">
+              <a:spcBef>
+                <a:spcPts val="0"/>
+              </a:spcBef>
+              <a:spcAft>
+                <a:spcPts val="200"/>
+              </a:spcAft>
+            </a:pPr>
+            <a:r>
+              <a:rPr sz="1050" b="1">
+                <a:solidFill>
+                  <a:srgbClr val="FFB02E"/>
+                </a:solidFill>
+              </a:rPr>
+              <a:t>TEACH</a:t>
+            </a:r>
+          </a:p>
+        </p:txBody>
+      </p:sp>
+      <p:sp>
+        <p:nvSpPr>
+          <p:cNvPr id="32" name="Chevron 31"/>
+          <p:cNvSpPr/>
+          <p:nvPr/>
+        </p:nvSpPr>
+        <p:spPr>
+          <a:xfrm>
+            <a:off x="1627632" y="5266944"/>
+            <a:ext cx="2679192" cy="512064"/>
+          </a:xfrm>
+          <a:prstGeom prst="chevron">
+            <a:avLst>
+              <a:gd name="adj" fmla="val 28000"/>
+            </a:avLst>
+          </a:prstGeom>
+          <a:solidFill>
+            <a:srgbClr val="222836"/>
+          </a:solidFill>
+          <a:ln w="12700">
+            <a:solidFill>
+              <a:srgbClr val="FFB02E"/>
+            </a:solidFill>
+          </a:ln>
+          <a:effectLst/>
+        </p:spPr>
+        <p:style>
+          <a:lnRef idx="1">
+            <a:schemeClr val="accent1"/>
+          </a:lnRef>
+          <a:fillRef idx="3">
+            <a:schemeClr val="accent1"/>
+          </a:fillRef>
+          <a:effectRef idx="2">
+            <a:schemeClr val="accent1"/>
+          </a:effectRef>
+          <a:fontRef idx="minor">
+            <a:schemeClr val="lt1"/>
+          </a:fontRef>
+        </p:style>
+        <p:txBody>
+          <a:bodyPr rtlCol="0" anchor="ctr" wrap="square" lIns="73152" rIns="73152" tIns="27432" bIns="27432"/>
+          <a:lstStyle/>
+          <a:p>
+            <a:pPr algn="ctr">
+              <a:spcBef>
+                <a:spcPts val="0"/>
+              </a:spcBef>
+              <a:spcAft>
+                <a:spcPts val="200"/>
+              </a:spcAft>
+            </a:pPr>
+            <a:r>
+              <a:rPr sz="880" b="0">
+                <a:solidFill>
+                  <a:srgbClr val="F0F2F8"/>
+                </a:solidFill>
+              </a:rPr>
+              <a:t>Speak an unknown command</a:t>
+            </a:r>
+          </a:p>
+        </p:txBody>
+      </p:sp>
+      <p:sp>
+        <p:nvSpPr>
+          <p:cNvPr id="33" name="Chevron 32"/>
+          <p:cNvSpPr/>
+          <p:nvPr/>
+        </p:nvSpPr>
+        <p:spPr>
+          <a:xfrm>
+            <a:off x="4142232" y="5266944"/>
+            <a:ext cx="2679192" cy="512064"/>
+          </a:xfrm>
+          <a:prstGeom prst="chevron">
+            <a:avLst>
+              <a:gd name="adj" fmla="val 28000"/>
+            </a:avLst>
+          </a:prstGeom>
+          <a:solidFill>
+            <a:srgbClr val="222836"/>
+          </a:solidFill>
+          <a:ln w="12700">
+            <a:solidFill>
+              <a:srgbClr val="FFB02E"/>
+            </a:solidFill>
+          </a:ln>
+          <a:effectLst/>
+        </p:spPr>
+        <p:style>
+          <a:lnRef idx="1">
+            <a:schemeClr val="accent1"/>
+          </a:lnRef>
+          <a:fillRef idx="3">
+            <a:schemeClr val="accent1"/>
+          </a:fillRef>
+          <a:effectRef idx="2">
+            <a:schemeClr val="accent1"/>
+          </a:effectRef>
+          <a:fontRef idx="minor">
+            <a:schemeClr val="lt1"/>
+          </a:fontRef>
+        </p:style>
+        <p:txBody>
+          <a:bodyPr rtlCol="0" anchor="ctr" wrap="square" lIns="73152" rIns="73152" tIns="27432" bIns="27432"/>
+          <a:lstStyle/>
+          <a:p>
+            <a:pPr algn="ctr">
+              <a:spcBef>
+                <a:spcPts val="0"/>
+              </a:spcBef>
+              <a:spcAft>
+                <a:spcPts val="200"/>
+              </a:spcAft>
+            </a:pPr>
+            <a:r>
+              <a:rPr sz="880" b="0">
+                <a:solidFill>
+                  <a:srgbClr val="F0F2F8"/>
+                </a:solidFill>
+              </a:rPr>
+              <a:t>Do the task once by hand</a:t>
+            </a:r>
+          </a:p>
+        </p:txBody>
+      </p:sp>
+      <p:sp>
+        <p:nvSpPr>
+          <p:cNvPr id="34" name="Chevron 33"/>
+          <p:cNvSpPr/>
+          <p:nvPr/>
+        </p:nvSpPr>
+        <p:spPr>
+          <a:xfrm>
+            <a:off x="6656832" y="5266944"/>
+            <a:ext cx="2679192" cy="512064"/>
+          </a:xfrm>
+          <a:prstGeom prst="chevron">
+            <a:avLst>
+              <a:gd name="adj" fmla="val 28000"/>
+            </a:avLst>
+          </a:prstGeom>
+          <a:solidFill>
+            <a:srgbClr val="222836"/>
+          </a:solidFill>
+          <a:ln w="12700">
+            <a:solidFill>
+              <a:srgbClr val="FFB02E"/>
+            </a:solidFill>
+          </a:ln>
+          <a:effectLst/>
+        </p:spPr>
+        <p:style>
+          <a:lnRef idx="1">
+            <a:schemeClr val="accent1"/>
+          </a:lnRef>
+          <a:fillRef idx="3">
+            <a:schemeClr val="accent1"/>
+          </a:fillRef>
+          <a:effectRef idx="2">
+            <a:schemeClr val="accent1"/>
+          </a:effectRef>
+          <a:fontRef idx="minor">
+            <a:schemeClr val="lt1"/>
+          </a:fontRef>
+        </p:style>
+        <p:txBody>
+          <a:bodyPr rtlCol="0" anchor="ctr" wrap="square" lIns="73152" rIns="73152" tIns="27432" bIns="27432"/>
+          <a:lstStyle/>
+          <a:p>
+            <a:pPr algn="ctr">
+              <a:spcBef>
+                <a:spcPts val="0"/>
+              </a:spcBef>
+              <a:spcAft>
+                <a:spcPts val="200"/>
+              </a:spcAft>
+            </a:pPr>
+            <a:r>
+              <a:rPr sz="880" b="0">
+                <a:solidFill>
+                  <a:srgbClr val="F0F2F8"/>
+                </a:solidFill>
+              </a:rPr>
+              <a:t>Recorder → steps + selectors</a:t>
+            </a:r>
+          </a:p>
+        </p:txBody>
+      </p:sp>
+      <p:sp>
+        <p:nvSpPr>
+          <p:cNvPr id="35" name="Chevron 34"/>
+          <p:cNvSpPr/>
+          <p:nvPr/>
+        </p:nvSpPr>
+        <p:spPr>
+          <a:xfrm>
+            <a:off x="9171432" y="5266944"/>
+            <a:ext cx="2679192" cy="512064"/>
+          </a:xfrm>
+          <a:prstGeom prst="chevron">
+            <a:avLst>
+              <a:gd name="adj" fmla="val 28000"/>
+            </a:avLst>
+          </a:prstGeom>
+          <a:solidFill>
+            <a:srgbClr val="222836"/>
+          </a:solidFill>
+          <a:ln w="12700">
+            <a:solidFill>
+              <a:srgbClr val="FFB02E"/>
+            </a:solidFill>
+          </a:ln>
+          <a:effectLst/>
+        </p:spPr>
+        <p:style>
+          <a:lnRef idx="1">
+            <a:schemeClr val="accent1"/>
+          </a:lnRef>
+          <a:fillRef idx="3">
+            <a:schemeClr val="accent1"/>
+          </a:fillRef>
+          <a:effectRef idx="2">
+            <a:schemeClr val="accent1"/>
+          </a:effectRef>
+          <a:fontRef idx="minor">
+            <a:schemeClr val="lt1"/>
+          </a:fontRef>
+        </p:style>
+        <p:txBody>
+          <a:bodyPr rtlCol="0" anchor="ctr" wrap="square" lIns="73152" rIns="73152" tIns="27432" bIns="27432"/>
+          <a:lstStyle/>
+          <a:p>
+            <a:pPr algn="ctr">
+              <a:spcBef>
+                <a:spcPts val="0"/>
+              </a:spcBef>
+              <a:spcAft>
+                <a:spcPts val="200"/>
+              </a:spcAft>
+            </a:pPr>
+            <a:r>
+              <a:rPr sz="880" b="0">
+                <a:solidFill>
+                  <a:srgbClr val="F0F2F8"/>
+                </a:solidFill>
+              </a:rPr>
+              <a:t>Groq generalises → Flow with {{slots}}</a:t>
+            </a:r>
+          </a:p>
+        </p:txBody>
+      </p:sp>
+      <p:sp>
+        <p:nvSpPr>
+          <p:cNvPr id="36" name="Rounded Rectangle 35"/>
+          <p:cNvSpPr/>
+          <p:nvPr/>
+        </p:nvSpPr>
+        <p:spPr>
+          <a:xfrm>
+            <a:off x="502920" y="5888736"/>
+            <a:ext cx="932688" cy="512064"/>
+          </a:xfrm>
+          <a:prstGeom prst="roundRect">
+            <a:avLst>
+              <a:gd name="adj" fmla="val 12000"/>
+            </a:avLst>
+          </a:prstGeom>
+          <a:solidFill>
+            <a:srgbClr val="222836"/>
+          </a:solidFill>
+          <a:ln w="13970">
+            <a:solidFill>
+              <a:srgbClr val="4EA1FF"/>
+            </a:solidFill>
+          </a:ln>
+          <a:effectLst/>
+        </p:spPr>
+        <p:style>
+          <a:lnRef idx="1">
+            <a:schemeClr val="accent1"/>
+          </a:lnRef>
+          <a:fillRef idx="3">
+            <a:schemeClr val="accent1"/>
+          </a:fillRef>
+          <a:effectRef idx="2">
+            <a:schemeClr val="accent1"/>
+          </a:effectRef>
+          <a:fontRef idx="minor">
+            <a:schemeClr val="lt1"/>
+          </a:fontRef>
+        </p:style>
+        <p:txBody>
+          <a:bodyPr rtlCol="0" anchor="ctr" wrap="square" lIns="73152" rIns="73152" tIns="27432" bIns="27432"/>
+          <a:lstStyle/>
+          <a:p>
+            <a:pPr algn="ctr">
+              <a:spcBef>
+                <a:spcPts val="0"/>
+              </a:spcBef>
+              <a:spcAft>
+                <a:spcPts val="200"/>
+              </a:spcAft>
+            </a:pPr>
+            <a:r>
+              <a:rPr sz="1050" b="1">
+                <a:solidFill>
+                  <a:srgbClr val="4EA1FF"/>
+                </a:solidFill>
+              </a:rPr>
+              <a:t>REPLAY</a:t>
+            </a:r>
+          </a:p>
+        </p:txBody>
+      </p:sp>
+      <p:sp>
+        <p:nvSpPr>
+          <p:cNvPr id="37" name="Chevron 36"/>
+          <p:cNvSpPr/>
+          <p:nvPr/>
+        </p:nvSpPr>
+        <p:spPr>
+          <a:xfrm>
+            <a:off x="1627632" y="5888736"/>
+            <a:ext cx="2679192" cy="512064"/>
+          </a:xfrm>
+          <a:prstGeom prst="chevron">
+            <a:avLst>
+              <a:gd name="adj" fmla="val 28000"/>
+            </a:avLst>
+          </a:prstGeom>
+          <a:solidFill>
+            <a:srgbClr val="222836"/>
+          </a:solidFill>
+          <a:ln w="12700">
+            <a:solidFill>
+              <a:srgbClr val="4EA1FF"/>
+            </a:solidFill>
+          </a:ln>
+          <a:effectLst/>
+        </p:spPr>
+        <p:style>
+          <a:lnRef idx="1">
+            <a:schemeClr val="accent1"/>
+          </a:lnRef>
+          <a:fillRef idx="3">
+            <a:schemeClr val="accent1"/>
+          </a:fillRef>
+          <a:effectRef idx="2">
+            <a:schemeClr val="accent1"/>
+          </a:effectRef>
+          <a:fontRef idx="minor">
+            <a:schemeClr val="lt1"/>
+          </a:fontRef>
+        </p:style>
+        <p:txBody>
+          <a:bodyPr rtlCol="0" anchor="ctr" wrap="square" lIns="73152" rIns="73152" tIns="27432" bIns="27432"/>
+          <a:lstStyle/>
+          <a:p>
+            <a:pPr algn="ctr">
+              <a:spcBef>
+                <a:spcPts val="0"/>
+              </a:spcBef>
+              <a:spcAft>
+                <a:spcPts val="200"/>
+              </a:spcAft>
+            </a:pPr>
+            <a:r>
+              <a:rPr sz="880" b="0">
+                <a:solidFill>
+                  <a:srgbClr val="F0F2F8"/>
+                </a:solidFill>
+              </a:rPr>
+              <a:t>Speak it with new values</a:t>
+            </a:r>
+          </a:p>
+        </p:txBody>
+      </p:sp>
+      <p:sp>
+        <p:nvSpPr>
+          <p:cNvPr id="38" name="Chevron 37"/>
+          <p:cNvSpPr/>
+          <p:nvPr/>
+        </p:nvSpPr>
+        <p:spPr>
+          <a:xfrm>
+            <a:off x="4142232" y="5888736"/>
+            <a:ext cx="2679192" cy="512064"/>
+          </a:xfrm>
+          <a:prstGeom prst="chevron">
+            <a:avLst>
+              <a:gd name="adj" fmla="val 28000"/>
+            </a:avLst>
+          </a:prstGeom>
+          <a:solidFill>
+            <a:srgbClr val="222836"/>
+          </a:solidFill>
+          <a:ln w="12700">
+            <a:solidFill>
+              <a:srgbClr val="4EA1FF"/>
+            </a:solidFill>
+          </a:ln>
+          <a:effectLst/>
+        </p:spPr>
+        <p:style>
+          <a:lnRef idx="1">
+            <a:schemeClr val="accent1"/>
+          </a:lnRef>
+          <a:fillRef idx="3">
+            <a:schemeClr val="accent1"/>
+          </a:fillRef>
+          <a:effectRef idx="2">
+            <a:schemeClr val="accent1"/>
+          </a:effectRef>
+          <a:fontRef idx="minor">
+            <a:schemeClr val="lt1"/>
+          </a:fontRef>
+        </p:style>
+        <p:txBody>
+          <a:bodyPr rtlCol="0" anchor="ctr" wrap="square" lIns="73152" rIns="73152" tIns="27432" bIns="27432"/>
+          <a:lstStyle/>
+          <a:p>
+            <a:pPr algn="ctr">
+              <a:spcBef>
+                <a:spcPts val="0"/>
+              </a:spcBef>
+              <a:spcAft>
+                <a:spcPts val="200"/>
+              </a:spcAft>
+            </a:pPr>
+            <a:r>
+              <a:rPr sz="880" b="0">
+                <a:solidFill>
+                  <a:srgbClr val="F0F2F8"/>
+                </a:solidFill>
+              </a:rPr>
+              <a:t>STT · paraphrase match · slots</a:t>
+            </a:r>
+          </a:p>
+        </p:txBody>
+      </p:sp>
+      <p:sp>
+        <p:nvSpPr>
+          <p:cNvPr id="39" name="Chevron 38"/>
+          <p:cNvSpPr/>
+          <p:nvPr/>
+        </p:nvSpPr>
+        <p:spPr>
+          <a:xfrm>
+            <a:off x="6656832" y="5888736"/>
+            <a:ext cx="2679192" cy="512064"/>
+          </a:xfrm>
+          <a:prstGeom prst="chevron">
+            <a:avLst>
+              <a:gd name="adj" fmla="val 28000"/>
+            </a:avLst>
+          </a:prstGeom>
+          <a:solidFill>
+            <a:srgbClr val="222836"/>
+          </a:solidFill>
+          <a:ln w="12700">
+            <a:solidFill>
+              <a:srgbClr val="4EA1FF"/>
+            </a:solidFill>
+          </a:ln>
+          <a:effectLst/>
+        </p:spPr>
+        <p:style>
+          <a:lnRef idx="1">
+            <a:schemeClr val="accent1"/>
+          </a:lnRef>
+          <a:fillRef idx="3">
+            <a:schemeClr val="accent1"/>
+          </a:fillRef>
+          <a:effectRef idx="2">
+            <a:schemeClr val="accent1"/>
+          </a:effectRef>
+          <a:fontRef idx="minor">
+            <a:schemeClr val="lt1"/>
+          </a:fontRef>
+        </p:style>
+        <p:txBody>
+          <a:bodyPr rtlCol="0" anchor="ctr" wrap="square" lIns="73152" rIns="73152" tIns="27432" bIns="27432"/>
+          <a:lstStyle/>
+          <a:p>
+            <a:pPr algn="ctr">
+              <a:spcBef>
+                <a:spcPts val="0"/>
+              </a:spcBef>
+              <a:spcAft>
+                <a:spcPts val="200"/>
+              </a:spcAft>
+            </a:pPr>
+            <a:r>
+              <a:rPr sz="880" b="0">
+                <a:solidFill>
+                  <a:srgbClr val="F0F2F8"/>
+                </a:solidFill>
+              </a:rPr>
+              <a:t>Replayer acts on live UI tree</a:t>
+            </a:r>
+          </a:p>
+        </p:txBody>
+      </p:sp>
+      <p:sp>
+        <p:nvSpPr>
+          <p:cNvPr id="40" name="Chevron 39"/>
+          <p:cNvSpPr/>
+          <p:nvPr/>
+        </p:nvSpPr>
+        <p:spPr>
+          <a:xfrm>
+            <a:off x="9171432" y="5888736"/>
+            <a:ext cx="2679192" cy="512064"/>
+          </a:xfrm>
+          <a:prstGeom prst="chevron">
+            <a:avLst>
+              <a:gd name="adj" fmla="val 28000"/>
+            </a:avLst>
+          </a:prstGeom>
+          <a:solidFill>
+            <a:srgbClr val="222836"/>
+          </a:solidFill>
+          <a:ln w="12700">
+            <a:solidFill>
+              <a:srgbClr val="4EA1FF"/>
+            </a:solidFill>
+          </a:ln>
+          <a:effectLst/>
+        </p:spPr>
+        <p:style>
+          <a:lnRef idx="1">
+            <a:schemeClr val="accent1"/>
+          </a:lnRef>
+          <a:fillRef idx="3">
+            <a:schemeClr val="accent1"/>
+          </a:fillRef>
+          <a:effectRef idx="2">
+            <a:schemeClr val="accent1"/>
+          </a:effectRef>
+          <a:fontRef idx="minor">
+            <a:schemeClr val="lt1"/>
+          </a:fontRef>
+        </p:style>
+        <p:txBody>
+          <a:bodyPr rtlCol="0" anchor="ctr" wrap="square" lIns="73152" rIns="73152" tIns="27432" bIns="27432"/>
+          <a:lstStyle/>
+          <a:p>
+            <a:pPr algn="ctr">
+              <a:spcBef>
+                <a:spcPts val="0"/>
+              </a:spcBef>
+              <a:spcAft>
+                <a:spcPts val="200"/>
+              </a:spcAft>
+            </a:pPr>
+            <a:r>
+              <a:rPr sz="880" b="0">
+                <a:solidFill>
+                  <a:srgbClr val="F0F2F8"/>
+                </a:solidFill>
+              </a:rPr>
+              <a:t>ScreenGuard stops at pay/OTP → spoken result</a:t>
             </a:r>
           </a:p>
         </p:txBody>

</xml_diff>